<commit_message>
Replace fold-level Part 1 figures/text with per-site and by-year views
Same pseudo-replication fix as the by-PFT analysis itself, applied to the
deck and report: swapped the pooled fold-level boxplot for the per-site
(honest n) boxplot plus a new by-year robustness-check slide, and updated
the summary table/text to the per-site medians. Deck is now 10 slides.

Co-Authored-By: Claude Sonnet 5 <noreply@anthropic.com>
</commit_message>
<xml_diff>
--- a/presentations/GPP_vs_LAI_Progress_Update/GPP_vs_LAI_Progress_Update.pptx
+++ b/presentations/GPP_vs_LAI_Progress_Update/GPP_vs_LAI_Progress_Update.pptx
@@ -14,6 +14,7 @@
     <p:sldId id="262" r:id="rId13"/>
     <p:sldId id="263" r:id="rId14"/>
     <p:sldId id="264" r:id="rId15"/>
+    <p:sldId id="265" r:id="rId16"/>
   </p:sldIdLst>
   <p:sldSz cx="12191695" cy="6858000" type="screen4x3"/>
   <p:notesSz cx="6858000" cy="9144000"/>
@@ -3341,6 +3342,517 @@
 </p:sld>
 </file>
 
+<file path=ppt/slides/slide10.xml><?xml version="1.0" encoding="utf-8"?>
+<p:sld xmlns:a="http://schemas.openxmlformats.org/drawingml/2006/main" xmlns:p="http://schemas.openxmlformats.org/presentationml/2006/main" xmlns:r="http://schemas.openxmlformats.org/officeDocument/2006/relationships">
+  <p:cSld>
+    <p:bg>
+      <p:bgPr>
+        <a:solidFill>
+          <a:srgbClr val="FFFFFF"/>
+        </a:solidFill>
+        <a:effectLst/>
+      </p:bgPr>
+    </p:bg>
+    <p:spTree>
+      <p:nvGrpSpPr>
+        <p:cNvPr id="1" name=""/>
+        <p:cNvGrpSpPr/>
+        <p:nvPr/>
+      </p:nvGrpSpPr>
+      <p:grpSpPr/>
+      <p:sp>
+        <p:nvSpPr>
+          <p:cNvPr id="2" name="TextBox 1"/>
+          <p:cNvSpPr txBox="1"/>
+          <p:nvPr/>
+        </p:nvSpPr>
+        <p:spPr>
+          <a:xfrm>
+            <a:off x="502920" y="384048"/>
+            <a:ext cx="10972800" cy="292608"/>
+          </a:xfrm>
+          <a:prstGeom prst="rect">
+            <a:avLst/>
+          </a:prstGeom>
+          <a:noFill/>
+        </p:spPr>
+        <p:txBody>
+          <a:bodyPr wrap="square" anchor="t" lIns="0" rIns="0" tIns="0" bIns="0">
+            <a:spAutoFit/>
+          </a:bodyPr>
+          <a:lstStyle/>
+          <a:p>
+            <a:pPr algn="l">
+              <a:lnSpc>
+                <a:spcPct val="100000"/>
+              </a:lnSpc>
+            </a:pPr>
+            <a:r>
+              <a:rPr sz="1300" b="1" i="0">
+                <a:solidFill>
+                  <a:srgbClr val="2F6F5E"/>
+                </a:solidFill>
+                <a:latin typeface="Calibri"/>
+              </a:rPr>
+              <a:t>NEXT STEPS</a:t>
+            </a:r>
+          </a:p>
+        </p:txBody>
+      </p:sp>
+      <p:sp>
+        <p:nvSpPr>
+          <p:cNvPr id="3" name="TextBox 2"/>
+          <p:cNvSpPr txBox="1"/>
+          <p:nvPr/>
+        </p:nvSpPr>
+        <p:spPr>
+          <a:xfrm>
+            <a:off x="502920" y="658368"/>
+            <a:ext cx="11155680" cy="566928"/>
+          </a:xfrm>
+          <a:prstGeom prst="rect">
+            <a:avLst/>
+          </a:prstGeom>
+          <a:noFill/>
+        </p:spPr>
+        <p:txBody>
+          <a:bodyPr wrap="square" anchor="t" lIns="0" rIns="0" tIns="0" bIns="0">
+            <a:spAutoFit/>
+          </a:bodyPr>
+          <a:lstStyle/>
+          <a:p>
+            <a:pPr algn="l">
+              <a:lnSpc>
+                <a:spcPct val="100000"/>
+              </a:lnSpc>
+            </a:pPr>
+            <a:r>
+              <a:rPr sz="2300" b="1" i="0">
+                <a:solidFill>
+                  <a:srgbClr val="1C2119"/>
+                </a:solidFill>
+                <a:latin typeface="Calibri"/>
+              </a:rPr>
+              <a:t>Interpretation and Next Steps</a:t>
+            </a:r>
+          </a:p>
+        </p:txBody>
+      </p:sp>
+      <p:sp>
+        <p:nvSpPr>
+          <p:cNvPr id="4" name="Rectangle 3"/>
+          <p:cNvSpPr/>
+          <p:nvPr/>
+        </p:nvSpPr>
+        <p:spPr>
+          <a:xfrm>
+            <a:off x="502920" y="1261872"/>
+            <a:ext cx="914400" cy="38100"/>
+          </a:xfrm>
+          <a:prstGeom prst="rect">
+            <a:avLst/>
+          </a:prstGeom>
+          <a:solidFill>
+            <a:srgbClr val="2F6F5E"/>
+          </a:solidFill>
+          <a:ln>
+            <a:noFill/>
+          </a:ln>
+          <a:effectLst/>
+        </p:spPr>
+        <p:style>
+          <a:lnRef idx="1">
+            <a:schemeClr val="accent1"/>
+          </a:lnRef>
+          <a:fillRef idx="3">
+            <a:schemeClr val="accent1"/>
+          </a:fillRef>
+          <a:effectRef idx="2">
+            <a:schemeClr val="accent1"/>
+          </a:effectRef>
+          <a:fontRef idx="minor">
+            <a:schemeClr val="lt1"/>
+          </a:fontRef>
+        </p:style>
+        <p:txBody>
+          <a:bodyPr rtlCol="0" anchor="ctr"/>
+          <a:lstStyle/>
+          <a:p>
+            <a:pPr algn="ctr"/>
+          </a:p>
+        </p:txBody>
+      </p:sp>
+      <p:sp>
+        <p:nvSpPr>
+          <p:cNvPr id="5" name="TextBox 4"/>
+          <p:cNvSpPr txBox="1"/>
+          <p:nvPr/>
+        </p:nvSpPr>
+        <p:spPr>
+          <a:xfrm>
+            <a:off x="11551615" y="384048"/>
+            <a:ext cx="365760" cy="274320"/>
+          </a:xfrm>
+          <a:prstGeom prst="rect">
+            <a:avLst/>
+          </a:prstGeom>
+          <a:noFill/>
+        </p:spPr>
+        <p:txBody>
+          <a:bodyPr wrap="square" anchor="t" lIns="0" rIns="0" tIns="0" bIns="0">
+            <a:spAutoFit/>
+          </a:bodyPr>
+          <a:lstStyle/>
+          <a:p>
+            <a:pPr algn="r">
+              <a:lnSpc>
+                <a:spcPct val="100000"/>
+              </a:lnSpc>
+            </a:pPr>
+            <a:r>
+              <a:rPr sz="1100" b="0" i="0">
+                <a:solidFill>
+                  <a:srgbClr val="8B9382"/>
+                </a:solidFill>
+                <a:latin typeface="Calibri"/>
+              </a:rPr>
+              <a:t>10</a:t>
+            </a:r>
+          </a:p>
+        </p:txBody>
+      </p:sp>
+      <p:sp>
+        <p:nvSpPr>
+          <p:cNvPr id="6" name="TextBox 5"/>
+          <p:cNvSpPr txBox="1"/>
+          <p:nvPr/>
+        </p:nvSpPr>
+        <p:spPr>
+          <a:xfrm>
+            <a:off x="502920" y="1143000"/>
+            <a:ext cx="10789920" cy="2377440"/>
+          </a:xfrm>
+          <a:prstGeom prst="rect">
+            <a:avLst/>
+          </a:prstGeom>
+          <a:noFill/>
+        </p:spPr>
+        <p:txBody>
+          <a:bodyPr wrap="square" anchor="t" lIns="0" rIns="0">
+            <a:spAutoFit/>
+          </a:bodyPr>
+          <a:lstStyle/>
+          <a:p>
+            <a:pPr>
+              <a:lnSpc>
+                <a:spcPct val="106000"/>
+              </a:lnSpc>
+              <a:spcAft>
+                <a:spcPts val="1200"/>
+              </a:spcAft>
+            </a:pPr>
+            <a:r>
+              <a:rPr sz="1550">
+                <a:solidFill>
+                  <a:srgbClr val="2F6F5E"/>
+                </a:solidFill>
+                <a:latin typeface="Calibri"/>
+              </a:rPr>
+              <a:t>▪  </a:t>
+            </a:r>
+            <a:r>
+              <a:rPr sz="1550">
+                <a:solidFill>
+                  <a:srgbClr val="1C2119"/>
+                </a:solidFill>
+                <a:latin typeface="Calibri"/>
+              </a:rPr>
+              <a:t>Consistent with Prof. Wang's expectation that GPP is the more weather-coupled, more directly forecastable target - GPP responds to the same short-term weather drivers Chronos-2 sees in its covariates more directly than LAI, which is a slower-integrating structural/canopy variable. (Interpretation - not yet tested directly.)</a:t>
+            </a:r>
+          </a:p>
+          <a:p>
+            <a:pPr>
+              <a:lnSpc>
+                <a:spcPct val="106000"/>
+              </a:lnSpc>
+              <a:spcAft>
+                <a:spcPts val="1200"/>
+              </a:spcAft>
+            </a:pPr>
+            <a:r>
+              <a:rPr sz="1550">
+                <a:solidFill>
+                  <a:srgbClr val="2F6F5E"/>
+                </a:solidFill>
+                <a:latin typeface="Calibri"/>
+              </a:rPr>
+              <a:t>▪  </a:t>
+            </a:r>
+            <a:r>
+              <a:rPr sz="1550">
+                <a:solidFill>
+                  <a:srgbClr val="1C2119"/>
+                </a:solidFill>
+                <a:latin typeface="Calibri"/>
+              </a:rPr>
+              <a:t>This zero-shot result does not yet test whether physics-guided fine-tuning helps GPP more than LAI - it only establishes that the baseline gap between the two targets is real and goes in the expected direction, before spending effort on the fine-tuning comparison.</a:t>
+            </a:r>
+          </a:p>
+        </p:txBody>
+      </p:sp>
+      <p:sp>
+        <p:nvSpPr>
+          <p:cNvPr id="7" name="TextBox 6"/>
+          <p:cNvSpPr txBox="1"/>
+          <p:nvPr/>
+        </p:nvSpPr>
+        <p:spPr>
+          <a:xfrm>
+            <a:off x="502920" y="3611880"/>
+            <a:ext cx="10789920" cy="1645920"/>
+          </a:xfrm>
+          <a:prstGeom prst="rect">
+            <a:avLst/>
+          </a:prstGeom>
+          <a:noFill/>
+        </p:spPr>
+        <p:txBody>
+          <a:bodyPr wrap="square" anchor="t" lIns="0" rIns="0">
+            <a:spAutoFit/>
+          </a:bodyPr>
+          <a:lstStyle/>
+          <a:p>
+            <a:pPr>
+              <a:lnSpc>
+                <a:spcPct val="106000"/>
+              </a:lnSpc>
+              <a:spcAft>
+                <a:spcPts val="1000"/>
+              </a:spcAft>
+            </a:pPr>
+            <a:r>
+              <a:rPr sz="1550">
+                <a:solidFill>
+                  <a:srgbClr val="2A78D6"/>
+                </a:solidFill>
+                <a:latin typeface="Calibri"/>
+              </a:rPr>
+              <a:t>▪  </a:t>
+            </a:r>
+            <a:r>
+              <a:rPr sz="1550">
+                <a:solidFill>
+                  <a:srgbClr val="1C2119"/>
+                </a:solidFill>
+                <a:latin typeface="Calibri"/>
+              </a:rPr>
+              <a:t>Next: confirm this result holds at the full 70-site scale (download in progress on AppEEARS).</a:t>
+            </a:r>
+          </a:p>
+          <a:p>
+            <a:pPr>
+              <a:lnSpc>
+                <a:spcPct val="106000"/>
+              </a:lnSpc>
+              <a:spcAft>
+                <a:spcPts val="1000"/>
+              </a:spcAft>
+            </a:pPr>
+            <a:r>
+              <a:rPr sz="1550">
+                <a:solidFill>
+                  <a:srgbClr val="2A78D6"/>
+                </a:solidFill>
+                <a:latin typeface="Calibri"/>
+              </a:rPr>
+              <a:t>▪  </a:t>
+            </a:r>
+            <a:r>
+              <a:rPr sz="1550">
+                <a:solidFill>
+                  <a:srgbClr val="1C2119"/>
+                </a:solidFill>
+                <a:latin typeface="Calibri"/>
+              </a:rPr>
+              <a:t>Then: physics-guided fine-tuning on GPP, using the existing phenology equation and fine-tuning machinery (already supports GPP as --target-col) - deliberately not started yet, per the agreed order of work.</a:t>
+            </a:r>
+          </a:p>
+        </p:txBody>
+      </p:sp>
+      <p:sp>
+        <p:nvSpPr>
+          <p:cNvPr id="8" name="Rectangle 7"/>
+          <p:cNvSpPr/>
+          <p:nvPr/>
+        </p:nvSpPr>
+        <p:spPr>
+          <a:xfrm>
+            <a:off x="0" y="6144768"/>
+            <a:ext cx="12191695" cy="713232"/>
+          </a:xfrm>
+          <a:prstGeom prst="rect">
+            <a:avLst/>
+          </a:prstGeom>
+          <a:solidFill>
+            <a:srgbClr val="E2ECFA"/>
+          </a:solidFill>
+          <a:ln>
+            <a:noFill/>
+          </a:ln>
+          <a:effectLst/>
+        </p:spPr>
+        <p:style>
+          <a:lnRef idx="1">
+            <a:schemeClr val="accent1"/>
+          </a:lnRef>
+          <a:fillRef idx="3">
+            <a:schemeClr val="accent1"/>
+          </a:fillRef>
+          <a:effectRef idx="2">
+            <a:schemeClr val="accent1"/>
+          </a:effectRef>
+          <a:fontRef idx="minor">
+            <a:schemeClr val="lt1"/>
+          </a:fontRef>
+        </p:style>
+        <p:txBody>
+          <a:bodyPr rtlCol="0" anchor="ctr"/>
+          <a:lstStyle/>
+          <a:p>
+            <a:pPr algn="ctr"/>
+          </a:p>
+        </p:txBody>
+      </p:sp>
+      <p:sp>
+        <p:nvSpPr>
+          <p:cNvPr id="9" name="Rectangle 8"/>
+          <p:cNvSpPr/>
+          <p:nvPr/>
+        </p:nvSpPr>
+        <p:spPr>
+          <a:xfrm>
+            <a:off x="0" y="6144768"/>
+            <a:ext cx="109728" cy="713232"/>
+          </a:xfrm>
+          <a:prstGeom prst="rect">
+            <a:avLst/>
+          </a:prstGeom>
+          <a:solidFill>
+            <a:srgbClr val="2A78D6"/>
+          </a:solidFill>
+          <a:ln>
+            <a:noFill/>
+          </a:ln>
+          <a:effectLst/>
+        </p:spPr>
+        <p:style>
+          <a:lnRef idx="1">
+            <a:schemeClr val="accent1"/>
+          </a:lnRef>
+          <a:fillRef idx="3">
+            <a:schemeClr val="accent1"/>
+          </a:fillRef>
+          <a:effectRef idx="2">
+            <a:schemeClr val="accent1"/>
+          </a:effectRef>
+          <a:fontRef idx="minor">
+            <a:schemeClr val="lt1"/>
+          </a:fontRef>
+        </p:style>
+        <p:txBody>
+          <a:bodyPr rtlCol="0" anchor="ctr"/>
+          <a:lstStyle/>
+          <a:p>
+            <a:pPr algn="ctr"/>
+          </a:p>
+        </p:txBody>
+      </p:sp>
+      <p:sp>
+        <p:nvSpPr>
+          <p:cNvPr id="10" name="TextBox 9"/>
+          <p:cNvSpPr txBox="1"/>
+          <p:nvPr/>
+        </p:nvSpPr>
+        <p:spPr>
+          <a:xfrm>
+            <a:off x="411480" y="6144768"/>
+            <a:ext cx="11368735" cy="713232"/>
+          </a:xfrm>
+          <a:prstGeom prst="rect">
+            <a:avLst/>
+          </a:prstGeom>
+          <a:noFill/>
+        </p:spPr>
+        <p:txBody>
+          <a:bodyPr wrap="square" anchor="ctr" lIns="0" rIns="0" tIns="0" bIns="0">
+            <a:spAutoFit/>
+          </a:bodyPr>
+          <a:lstStyle/>
+          <a:p>
+            <a:pPr algn="l">
+              <a:lnSpc>
+                <a:spcPct val="100000"/>
+              </a:lnSpc>
+            </a:pPr>
+            <a:r>
+              <a:rPr sz="1200" b="1" i="0">
+                <a:solidFill>
+                  <a:srgbClr val="1A3A66"/>
+                </a:solidFill>
+                <a:latin typeface="Calibri"/>
+              </a:rPr>
+              <a:t>TAKEAWAY   </a:t>
+            </a:r>
+          </a:p>
+        </p:txBody>
+      </p:sp>
+      <p:sp>
+        <p:nvSpPr>
+          <p:cNvPr id="11" name="TextBox 10"/>
+          <p:cNvSpPr txBox="1"/>
+          <p:nvPr/>
+        </p:nvSpPr>
+        <p:spPr>
+          <a:xfrm>
+            <a:off x="1417320" y="6144768"/>
+            <a:ext cx="10362895" cy="713232"/>
+          </a:xfrm>
+          <a:prstGeom prst="rect">
+            <a:avLst/>
+          </a:prstGeom>
+          <a:noFill/>
+        </p:spPr>
+        <p:txBody>
+          <a:bodyPr wrap="square" anchor="ctr" lIns="0" rIns="0" tIns="0" bIns="0">
+            <a:spAutoFit/>
+          </a:bodyPr>
+          <a:lstStyle/>
+          <a:p>
+            <a:pPr algn="l">
+              <a:lnSpc>
+                <a:spcPct val="100000"/>
+              </a:lnSpc>
+            </a:pPr>
+            <a:r>
+              <a:rPr sz="1450" b="1" i="0">
+                <a:solidFill>
+                  <a:srgbClr val="1A3A66"/>
+                </a:solidFill>
+                <a:latin typeface="Calibri"/>
+              </a:rPr>
+              <a:t>Order of work, as agreed: data first, zero-shot baseline second (done here), physics-guided fine-tuning on GPP last.</a:t>
+            </a:r>
+          </a:p>
+        </p:txBody>
+      </p:sp>
+    </p:spTree>
+  </p:cSld>
+  <p:clrMapOvr>
+    <a:masterClrMapping/>
+  </p:clrMapOvr>
+</p:sld>
+</file>
+
 <file path=ppt/slides/slide2.xml><?xml version="1.0" encoding="utf-8"?>
 <p:sld xmlns:a="http://schemas.openxmlformats.org/drawingml/2006/main" xmlns:p="http://schemas.openxmlformats.org/presentationml/2006/main" xmlns:r="http://schemas.openxmlformats.org/officeDocument/2006/relationships">
   <p:cSld>
@@ -3529,7 +4041,7 @@
         <p:spPr>
           <a:xfrm>
             <a:off x="502920" y="1143000"/>
-            <a:ext cx="10789920" cy="2377440"/>
+            <a:ext cx="10789920" cy="2651760"/>
           </a:xfrm>
           <a:prstGeom prst="rect">
             <a:avLst/>
@@ -3547,11 +4059,11 @@
                 <a:spcPct val="106000"/>
               </a:lnSpc>
               <a:spcAft>
-                <a:spcPts val="1000"/>
+                <a:spcPts val="900"/>
               </a:spcAft>
             </a:pPr>
             <a:r>
-              <a:rPr sz="1550">
+              <a:rPr sz="1500">
                 <a:solidFill>
                   <a:srgbClr val="2F6F5E"/>
                 </a:solidFill>
@@ -3560,7 +4072,7 @@
               <a:t>▪  </a:t>
             </a:r>
             <a:r>
-              <a:rPr sz="1550">
+              <a:rPr sz="1500">
                 <a:solidFill>
                   <a:srgbClr val="1C2119"/>
                 </a:solidFill>
@@ -3575,11 +4087,11 @@
                 <a:spcPct val="106000"/>
               </a:lnSpc>
               <a:spcAft>
-                <a:spcPts val="1000"/>
+                <a:spcPts val="900"/>
               </a:spcAft>
             </a:pPr>
             <a:r>
-              <a:rPr sz="1550">
+              <a:rPr sz="1500">
                 <a:solidFill>
                   <a:srgbClr val="2F6F5E"/>
                 </a:solidFill>
@@ -3588,7 +4100,7 @@
               <a:t>▪  </a:t>
             </a:r>
             <a:r>
-              <a:rPr sz="1550">
+              <a:rPr sz="1500">
                 <a:solidFill>
                   <a:srgbClr val="1C2119"/>
                 </a:solidFill>
@@ -3603,11 +4115,11 @@
                 <a:spcPct val="106000"/>
               </a:lnSpc>
               <a:spcAft>
-                <a:spcPts val="1000"/>
+                <a:spcPts val="900"/>
               </a:spcAft>
             </a:pPr>
             <a:r>
-              <a:rPr sz="1550">
+              <a:rPr sz="1500">
                 <a:solidFill>
                   <a:srgbClr val="2F6F5E"/>
                 </a:solidFill>
@@ -3616,13 +4128,13 @@
               <a:t>▪  </a:t>
             </a:r>
             <a:r>
-              <a:rPr sz="1550">
+              <a:rPr sz="1500">
                 <a:solidFill>
                   <a:srgbClr val="1C2119"/>
                 </a:solidFill>
                 <a:latin typeface="Calibri"/>
               </a:rPr>
-              <a:t>Grouping is done at the fold level (not one point per site), so each class's distribution reflects its full year-to-year spread, not just inter-site spread.</a:t>
+              <a:t>Pseudo-replication fix: grouping at the fold level pools 11 years per site into each class's distribution, which overstates independence (11 years at one site aren't 11 independent draws). The honest sample size per class is its site count, not its fold count.</a:t>
             </a:r>
           </a:p>
         </p:txBody>
@@ -3788,7 +4300,7 @@
                 </a:solidFill>
                 <a:latin typeface="Calibri"/>
               </a:rPr>
-              <a:t>Script: Code/loyo_cv_anomaly_by_pft.py. A few Global classes have only 2-3 sites - read those as suggestive, not definitive (see next slide).</a:t>
+              <a:t>Fixed two ways, both shown next: collapse each site to its 11-year mean first (one point per site), and check the ranking separately for each of the 11 years.</a:t>
             </a:r>
           </a:p>
         </p:txBody>
@@ -3982,7 +4494,7 @@
       </p:sp>
       <p:pic>
         <p:nvPicPr>
-          <p:cNvPr id="6" name="Picture 5" descr="loyo_anomaly_by_pft_boxplots.png"/>
+          <p:cNvPr id="6" name="Picture 5" descr="loyo_anomaly_by_pft_persite_boxplots.png"/>
           <p:cNvPicPr>
             <a:picLocks noChangeAspect="1"/>
           </p:cNvPicPr>
@@ -3996,8 +4508,8 @@
         </p:blipFill>
         <p:spPr>
           <a:xfrm>
-            <a:off x="3107094" y="1143000"/>
-            <a:ext cx="5977507" cy="4864608"/>
+            <a:off x="2569226" y="1143000"/>
+            <a:ext cx="7053243" cy="4864608"/>
           </a:xfrm>
           <a:prstGeom prst="rect">
             <a:avLst/>
@@ -4165,7 +4677,7 @@
                 </a:solidFill>
                 <a:latin typeface="Calibri"/>
               </a:rPr>
-              <a:t>The shrubs &gt; grass &gt; trees ordering holds independently in both CONUS and Global pools - not an artifact of one site or one region.</a:t>
+              <a:t>Each site collapsed to its 11-year mean first, then boxplotted (dots = individual sites) - a class with 6 sites shows 6 points here, not 66 pooled folds.</a:t>
             </a:r>
           </a:p>
         </p:txBody>
@@ -4269,7 +4781,7 @@
                 </a:solidFill>
                 <a:latin typeface="Calibri"/>
               </a:rPr>
-              <a:t>Part 1 Summary: Median Pearson r by Class Family</a:t>
+              <a:t>Robustness Check: Is the Ranking Stable Year by Year?</a:t>
             </a:r>
           </a:p>
         </p:txBody>
@@ -4353,6 +4865,383 @@
                 <a:latin typeface="Calibri"/>
               </a:rPr>
               <a:t>4</a:t>
+            </a:r>
+          </a:p>
+        </p:txBody>
+      </p:sp>
+      <p:pic>
+        <p:nvPicPr>
+          <p:cNvPr id="6" name="Picture 5" descr="loyo_anomaly_by_pft_byyear.png"/>
+          <p:cNvPicPr>
+            <a:picLocks noChangeAspect="1"/>
+          </p:cNvPicPr>
+          <p:nvPr/>
+        </p:nvPicPr>
+        <p:blipFill>
+          <a:blip r:embed="rId2"/>
+          <a:stretch>
+            <a:fillRect/>
+          </a:stretch>
+        </p:blipFill>
+        <p:spPr>
+          <a:xfrm>
+            <a:off x="502920" y="1577752"/>
+            <a:ext cx="11185855" cy="3995103"/>
+          </a:xfrm>
+          <a:prstGeom prst="rect">
+            <a:avLst/>
+          </a:prstGeom>
+        </p:spPr>
+      </p:pic>
+      <p:sp>
+        <p:nvSpPr>
+          <p:cNvPr id="7" name="Rectangle 6"/>
+          <p:cNvSpPr/>
+          <p:nvPr/>
+        </p:nvSpPr>
+        <p:spPr>
+          <a:xfrm>
+            <a:off x="0" y="6144768"/>
+            <a:ext cx="12191695" cy="713232"/>
+          </a:xfrm>
+          <a:prstGeom prst="rect">
+            <a:avLst/>
+          </a:prstGeom>
+          <a:solidFill>
+            <a:srgbClr val="E7F0E6"/>
+          </a:solidFill>
+          <a:ln>
+            <a:noFill/>
+          </a:ln>
+          <a:effectLst/>
+        </p:spPr>
+        <p:style>
+          <a:lnRef idx="1">
+            <a:schemeClr val="accent1"/>
+          </a:lnRef>
+          <a:fillRef idx="3">
+            <a:schemeClr val="accent1"/>
+          </a:fillRef>
+          <a:effectRef idx="2">
+            <a:schemeClr val="accent1"/>
+          </a:effectRef>
+          <a:fontRef idx="minor">
+            <a:schemeClr val="lt1"/>
+          </a:fontRef>
+        </p:style>
+        <p:txBody>
+          <a:bodyPr rtlCol="0" anchor="ctr"/>
+          <a:lstStyle/>
+          <a:p>
+            <a:pPr algn="ctr"/>
+          </a:p>
+        </p:txBody>
+      </p:sp>
+      <p:sp>
+        <p:nvSpPr>
+          <p:cNvPr id="8" name="Rectangle 7"/>
+          <p:cNvSpPr/>
+          <p:nvPr/>
+        </p:nvSpPr>
+        <p:spPr>
+          <a:xfrm>
+            <a:off x="0" y="6144768"/>
+            <a:ext cx="109728" cy="713232"/>
+          </a:xfrm>
+          <a:prstGeom prst="rect">
+            <a:avLst/>
+          </a:prstGeom>
+          <a:solidFill>
+            <a:srgbClr val="2F6F5E"/>
+          </a:solidFill>
+          <a:ln>
+            <a:noFill/>
+          </a:ln>
+          <a:effectLst/>
+        </p:spPr>
+        <p:style>
+          <a:lnRef idx="1">
+            <a:schemeClr val="accent1"/>
+          </a:lnRef>
+          <a:fillRef idx="3">
+            <a:schemeClr val="accent1"/>
+          </a:fillRef>
+          <a:effectRef idx="2">
+            <a:schemeClr val="accent1"/>
+          </a:effectRef>
+          <a:fontRef idx="minor">
+            <a:schemeClr val="lt1"/>
+          </a:fontRef>
+        </p:style>
+        <p:txBody>
+          <a:bodyPr rtlCol="0" anchor="ctr"/>
+          <a:lstStyle/>
+          <a:p>
+            <a:pPr algn="ctr"/>
+          </a:p>
+        </p:txBody>
+      </p:sp>
+      <p:sp>
+        <p:nvSpPr>
+          <p:cNvPr id="9" name="TextBox 8"/>
+          <p:cNvSpPr txBox="1"/>
+          <p:nvPr/>
+        </p:nvSpPr>
+        <p:spPr>
+          <a:xfrm>
+            <a:off x="411480" y="6144768"/>
+            <a:ext cx="11368735" cy="713232"/>
+          </a:xfrm>
+          <a:prstGeom prst="rect">
+            <a:avLst/>
+          </a:prstGeom>
+          <a:noFill/>
+        </p:spPr>
+        <p:txBody>
+          <a:bodyPr wrap="square" anchor="ctr" lIns="0" rIns="0" tIns="0" bIns="0">
+            <a:spAutoFit/>
+          </a:bodyPr>
+          <a:lstStyle/>
+          <a:p>
+            <a:pPr algn="l">
+              <a:lnSpc>
+                <a:spcPct val="100000"/>
+              </a:lnSpc>
+            </a:pPr>
+            <a:r>
+              <a:rPr sz="1200" b="1" i="0">
+                <a:solidFill>
+                  <a:srgbClr val="1E4A33"/>
+                </a:solidFill>
+                <a:latin typeface="Calibri"/>
+              </a:rPr>
+              <a:t>TAKEAWAY   </a:t>
+            </a:r>
+          </a:p>
+        </p:txBody>
+      </p:sp>
+      <p:sp>
+        <p:nvSpPr>
+          <p:cNvPr id="10" name="TextBox 9"/>
+          <p:cNvSpPr txBox="1"/>
+          <p:nvPr/>
+        </p:nvSpPr>
+        <p:spPr>
+          <a:xfrm>
+            <a:off x="1417320" y="6144768"/>
+            <a:ext cx="10362895" cy="713232"/>
+          </a:xfrm>
+          <a:prstGeom prst="rect">
+            <a:avLst/>
+          </a:prstGeom>
+          <a:noFill/>
+        </p:spPr>
+        <p:txBody>
+          <a:bodyPr wrap="square" anchor="ctr" lIns="0" rIns="0" tIns="0" bIns="0">
+            <a:spAutoFit/>
+          </a:bodyPr>
+          <a:lstStyle/>
+          <a:p>
+            <a:pPr algn="l">
+              <a:lnSpc>
+                <a:spcPct val="100000"/>
+              </a:lnSpc>
+            </a:pPr>
+            <a:r>
+              <a:rPr sz="1450" b="1" i="0">
+                <a:solidFill>
+                  <a:srgbClr val="1E4A33"/>
+                </a:solidFill>
+                <a:latin typeface="Calibri"/>
+              </a:rPr>
+              <a:t>Shrub-family lines (orange/brown) sit above tree-family lines (green) in most individual CONUS years, not just on average - this isn't one or two outlier years driving the effect.</a:t>
+            </a:r>
+          </a:p>
+        </p:txBody>
+      </p:sp>
+    </p:spTree>
+  </p:cSld>
+  <p:clrMapOvr>
+    <a:masterClrMapping/>
+  </p:clrMapOvr>
+</p:sld>
+</file>
+
+<file path=ppt/slides/slide5.xml><?xml version="1.0" encoding="utf-8"?>
+<p:sld xmlns:a="http://schemas.openxmlformats.org/drawingml/2006/main" xmlns:p="http://schemas.openxmlformats.org/presentationml/2006/main" xmlns:r="http://schemas.openxmlformats.org/officeDocument/2006/relationships">
+  <p:cSld>
+    <p:bg>
+      <p:bgPr>
+        <a:solidFill>
+          <a:srgbClr val="FFFFFF"/>
+        </a:solidFill>
+        <a:effectLst/>
+      </p:bgPr>
+    </p:bg>
+    <p:spTree>
+      <p:nvGrpSpPr>
+        <p:cNvPr id="1" name=""/>
+        <p:cNvGrpSpPr/>
+        <p:nvPr/>
+      </p:nvGrpSpPr>
+      <p:grpSpPr/>
+      <p:sp>
+        <p:nvSpPr>
+          <p:cNvPr id="2" name="TextBox 1"/>
+          <p:cNvSpPr txBox="1"/>
+          <p:nvPr/>
+        </p:nvSpPr>
+        <p:spPr>
+          <a:xfrm>
+            <a:off x="502920" y="384048"/>
+            <a:ext cx="10972800" cy="292608"/>
+          </a:xfrm>
+          <a:prstGeom prst="rect">
+            <a:avLst/>
+          </a:prstGeom>
+          <a:noFill/>
+        </p:spPr>
+        <p:txBody>
+          <a:bodyPr wrap="square" anchor="t" lIns="0" rIns="0" tIns="0" bIns="0">
+            <a:spAutoFit/>
+          </a:bodyPr>
+          <a:lstStyle/>
+          <a:p>
+            <a:pPr algn="l">
+              <a:lnSpc>
+                <a:spcPct val="100000"/>
+              </a:lnSpc>
+            </a:pPr>
+            <a:r>
+              <a:rPr sz="1300" b="1" i="0">
+                <a:solidFill>
+                  <a:srgbClr val="2F6F5E"/>
+                </a:solidFill>
+                <a:latin typeface="Calibri"/>
+              </a:rPr>
+              <a:t>PART 1 — VEGETATION-CLASS BREAKDOWN</a:t>
+            </a:r>
+          </a:p>
+        </p:txBody>
+      </p:sp>
+      <p:sp>
+        <p:nvSpPr>
+          <p:cNvPr id="3" name="TextBox 2"/>
+          <p:cNvSpPr txBox="1"/>
+          <p:nvPr/>
+        </p:nvSpPr>
+        <p:spPr>
+          <a:xfrm>
+            <a:off x="502920" y="658368"/>
+            <a:ext cx="11155680" cy="566928"/>
+          </a:xfrm>
+          <a:prstGeom prst="rect">
+            <a:avLst/>
+          </a:prstGeom>
+          <a:noFill/>
+        </p:spPr>
+        <p:txBody>
+          <a:bodyPr wrap="square" anchor="t" lIns="0" rIns="0" tIns="0" bIns="0">
+            <a:spAutoFit/>
+          </a:bodyPr>
+          <a:lstStyle/>
+          <a:p>
+            <a:pPr algn="l">
+              <a:lnSpc>
+                <a:spcPct val="100000"/>
+              </a:lnSpc>
+            </a:pPr>
+            <a:r>
+              <a:rPr sz="2300" b="1" i="0">
+                <a:solidFill>
+                  <a:srgbClr val="1C2119"/>
+                </a:solidFill>
+                <a:latin typeface="Calibri"/>
+              </a:rPr>
+              <a:t>Part 1 Summary: Median Pearson r by Class Family (Per-Site)</a:t>
+            </a:r>
+          </a:p>
+        </p:txBody>
+      </p:sp>
+      <p:sp>
+        <p:nvSpPr>
+          <p:cNvPr id="4" name="Rectangle 3"/>
+          <p:cNvSpPr/>
+          <p:nvPr/>
+        </p:nvSpPr>
+        <p:spPr>
+          <a:xfrm>
+            <a:off x="502920" y="1261872"/>
+            <a:ext cx="914400" cy="38100"/>
+          </a:xfrm>
+          <a:prstGeom prst="rect">
+            <a:avLst/>
+          </a:prstGeom>
+          <a:solidFill>
+            <a:srgbClr val="2F6F5E"/>
+          </a:solidFill>
+          <a:ln>
+            <a:noFill/>
+          </a:ln>
+          <a:effectLst/>
+        </p:spPr>
+        <p:style>
+          <a:lnRef idx="1">
+            <a:schemeClr val="accent1"/>
+          </a:lnRef>
+          <a:fillRef idx="3">
+            <a:schemeClr val="accent1"/>
+          </a:fillRef>
+          <a:effectRef idx="2">
+            <a:schemeClr val="accent1"/>
+          </a:effectRef>
+          <a:fontRef idx="minor">
+            <a:schemeClr val="lt1"/>
+          </a:fontRef>
+        </p:style>
+        <p:txBody>
+          <a:bodyPr rtlCol="0" anchor="ctr"/>
+          <a:lstStyle/>
+          <a:p>
+            <a:pPr algn="ctr"/>
+          </a:p>
+        </p:txBody>
+      </p:sp>
+      <p:sp>
+        <p:nvSpPr>
+          <p:cNvPr id="5" name="TextBox 4"/>
+          <p:cNvSpPr txBox="1"/>
+          <p:nvPr/>
+        </p:nvSpPr>
+        <p:spPr>
+          <a:xfrm>
+            <a:off x="11551615" y="384048"/>
+            <a:ext cx="365760" cy="274320"/>
+          </a:xfrm>
+          <a:prstGeom prst="rect">
+            <a:avLst/>
+          </a:prstGeom>
+          <a:noFill/>
+        </p:spPr>
+        <p:txBody>
+          <a:bodyPr wrap="square" anchor="t" lIns="0" rIns="0" tIns="0" bIns="0">
+            <a:spAutoFit/>
+          </a:bodyPr>
+          <a:lstStyle/>
+          <a:p>
+            <a:pPr algn="r">
+              <a:lnSpc>
+                <a:spcPct val="100000"/>
+              </a:lnSpc>
+            </a:pPr>
+            <a:r>
+              <a:rPr sz="1100" b="0" i="0">
+                <a:solidFill>
+                  <a:srgbClr val="8B9382"/>
+                </a:solidFill>
+                <a:latin typeface="Calibri"/>
+              </a:rPr>
+              <a:t>5</a:t>
             </a:r>
           </a:p>
         </p:txBody>
@@ -4488,7 +5377,7 @@
                           </a:solidFill>
                           <a:latin typeface="Calibri"/>
                         </a:rPr>
-                        <a:t>0.38 – 0.55</a:t>
+                        <a:t>0.26 – 0.50</a:t>
                       </a:r>
                     </a:p>
                   </a:txBody>
@@ -4511,7 +5400,7 @@
                           </a:solidFill>
                           <a:latin typeface="Calibri"/>
                         </a:rPr>
-                        <a:t>0.17 – 0.27</a:t>
+                        <a:t>0.14 – 0.25</a:t>
                       </a:r>
                     </a:p>
                   </a:txBody>
@@ -4559,7 +5448,7 @@
                           </a:solidFill>
                           <a:latin typeface="Calibri"/>
                         </a:rPr>
-                        <a:t>0.24 – 0.32</a:t>
+                        <a:t>0.19 – 0.23</a:t>
                       </a:r>
                     </a:p>
                   </a:txBody>
@@ -4582,7 +5471,7 @@
                           </a:solidFill>
                           <a:latin typeface="Calibri"/>
                         </a:rPr>
-                        <a:t>0.17 – 0.21</a:t>
+                        <a:t>0.17 – 0.19</a:t>
                       </a:r>
                     </a:p>
                   </a:txBody>
@@ -4630,7 +5519,7 @@
                           </a:solidFill>
                           <a:latin typeface="Calibri"/>
                         </a:rPr>
-                        <a:t>0.17 – 0.23</a:t>
+                        <a:t>0.16 – 0.22</a:t>
                       </a:r>
                     </a:p>
                   </a:txBody>
@@ -4653,7 +5542,7 @@
                           </a:solidFill>
                           <a:latin typeface="Calibri"/>
                         </a:rPr>
-                        <a:t>0.02 – 0.17</a:t>
+                        <a:t>0.07 – 0.19</a:t>
                       </a:r>
                     </a:p>
                   </a:txBody>
@@ -4677,7 +5566,7 @@
         <p:spPr>
           <a:xfrm>
             <a:off x="502920" y="3063240"/>
-            <a:ext cx="10789920" cy="1737360"/>
+            <a:ext cx="10789920" cy="2011680"/>
           </a:xfrm>
           <a:prstGeom prst="rect">
             <a:avLst/>
@@ -4695,11 +5584,11 @@
                 <a:spcPct val="106000"/>
               </a:lnSpc>
               <a:spcAft>
-                <a:spcPts val="1000"/>
+                <a:spcPts val="900"/>
               </a:spcAft>
             </a:pPr>
             <a:r>
-              <a:rPr sz="1450">
+              <a:rPr sz="1400">
                 <a:solidFill>
                   <a:srgbClr val="2F6F5E"/>
                 </a:solidFill>
@@ -4708,13 +5597,13 @@
               <a:t>▪  </a:t>
             </a:r>
             <a:r>
-              <a:rPr sz="1450">
+              <a:rPr sz="1400">
                 <a:solidFill>
                   <a:srgbClr val="1C2119"/>
                 </a:solidFill>
                 <a:latin typeface="Calibri"/>
               </a:rPr>
-              <a:t>Plausible mechanism (a hypothesis prompted by the pattern, not tested directly here): trees have slower, inertia-dominated canopy dynamics, so the year-to-year anomaly signal is small relative to noise; shrubs/grass respond faster to the same interannual weather drivers Chronos-2 sees in context.</a:t>
+              <a:t>Ranges computed from per-site 11-year means (honest n), not pooled folds - shrubs &gt; grass &gt; trees still holds; Global's grass/trees ranges now overlap slightly once the inflated fold count is corrected for, so that distinction is less crisp in Global than in CONUS.</a:t>
             </a:r>
           </a:p>
           <a:p>
@@ -4723,11 +5612,11 @@
                 <a:spcPct val="106000"/>
               </a:lnSpc>
               <a:spcAft>
-                <a:spcPts val="1000"/>
+                <a:spcPts val="900"/>
               </a:spcAft>
             </a:pPr>
             <a:r>
-              <a:rPr sz="1450">
+              <a:rPr sz="1400">
                 <a:solidFill>
                   <a:srgbClr val="2F6F5E"/>
                 </a:solidFill>
@@ -4736,13 +5625,13 @@
               <a:t>▪  </a:t>
             </a:r>
             <a:r>
-              <a:rPr sz="1450">
+              <a:rPr sz="1400">
                 <a:solidFill>
                   <a:srgbClr val="1C2119"/>
                 </a:solidFill>
                 <a:latin typeface="Calibri"/>
               </a:rPr>
-              <a:t>R² is noisier than Pearson r across classes - the same R²-instability pattern already documented in this project, so Pearson r is the metric to lead with.</a:t>
+              <a:t>Plausible mechanism (a hypothesis prompted by the pattern, not tested directly here): trees have slower, inertia-dominated canopy dynamics, so the year-to-year anomaly signal is small relative to noise; shrubs/grass respond faster to the same interannual weather drivers Chronos-2 sees in context.</a:t>
             </a:r>
           </a:p>
         </p:txBody>
@@ -4921,7 +5810,7 @@
 </p:sld>
 </file>
 
-<file path=ppt/slides/slide5.xml><?xml version="1.0" encoding="utf-8"?>
+<file path=ppt/slides/slide6.xml><?xml version="1.0" encoding="utf-8"?>
 <p:sld xmlns:a="http://schemas.openxmlformats.org/drawingml/2006/main" xmlns:p="http://schemas.openxmlformats.org/presentationml/2006/main" xmlns:r="http://schemas.openxmlformats.org/officeDocument/2006/relationships">
   <p:cSld>
     <p:bg>
@@ -5095,7 +5984,7 @@
                 </a:solidFill>
                 <a:latin typeface="Calibri"/>
               </a:rPr>
-              <a:t>5</a:t>
+              <a:t>6</a:t>
             </a:r>
           </a:p>
         </p:txBody>
@@ -5636,466 +6525,6 @@
 </p:sld>
 </file>
 
-<file path=ppt/slides/slide6.xml><?xml version="1.0" encoding="utf-8"?>
-<p:sld xmlns:a="http://schemas.openxmlformats.org/drawingml/2006/main" xmlns:p="http://schemas.openxmlformats.org/presentationml/2006/main" xmlns:r="http://schemas.openxmlformats.org/officeDocument/2006/relationships">
-  <p:cSld>
-    <p:bg>
-      <p:bgPr>
-        <a:solidFill>
-          <a:srgbClr val="FFFFFF"/>
-        </a:solidFill>
-        <a:effectLst/>
-      </p:bgPr>
-    </p:bg>
-    <p:spTree>
-      <p:nvGrpSpPr>
-        <p:cNvPr id="1" name=""/>
-        <p:cNvGrpSpPr/>
-        <p:nvPr/>
-      </p:nvGrpSpPr>
-      <p:grpSpPr/>
-      <p:sp>
-        <p:nvSpPr>
-          <p:cNvPr id="2" name="TextBox 1"/>
-          <p:cNvSpPr txBox="1"/>
-          <p:nvPr/>
-        </p:nvSpPr>
-        <p:spPr>
-          <a:xfrm>
-            <a:off x="502920" y="384048"/>
-            <a:ext cx="10972800" cy="292608"/>
-          </a:xfrm>
-          <a:prstGeom prst="rect">
-            <a:avLst/>
-          </a:prstGeom>
-          <a:noFill/>
-        </p:spPr>
-        <p:txBody>
-          <a:bodyPr wrap="square" anchor="t" lIns="0" rIns="0" tIns="0" bIns="0">
-            <a:spAutoFit/>
-          </a:bodyPr>
-          <a:lstStyle/>
-          <a:p>
-            <a:pPr algn="l">
-              <a:lnSpc>
-                <a:spcPct val="100000"/>
-              </a:lnSpc>
-            </a:pPr>
-            <a:r>
-              <a:rPr sz="1300" b="1" i="0">
-                <a:solidFill>
-                  <a:srgbClr val="2F6F5E"/>
-                </a:solidFill>
-                <a:latin typeface="Calibri"/>
-              </a:rPr>
-              <a:t>PART 2 — GPP DATA FIX</a:t>
-            </a:r>
-          </a:p>
-        </p:txBody>
-      </p:sp>
-      <p:sp>
-        <p:nvSpPr>
-          <p:cNvPr id="3" name="TextBox 2"/>
-          <p:cNvSpPr txBox="1"/>
-          <p:nvPr/>
-        </p:nvSpPr>
-        <p:spPr>
-          <a:xfrm>
-            <a:off x="502920" y="658368"/>
-            <a:ext cx="11155680" cy="566928"/>
-          </a:xfrm>
-          <a:prstGeom prst="rect">
-            <a:avLst/>
-          </a:prstGeom>
-          <a:noFill/>
-        </p:spPr>
-        <p:txBody>
-          <a:bodyPr wrap="square" anchor="t" lIns="0" rIns="0" tIns="0" bIns="0">
-            <a:spAutoFit/>
-          </a:bodyPr>
-          <a:lstStyle/>
-          <a:p>
-            <a:pPr algn="l">
-              <a:lnSpc>
-                <a:spcPct val="100000"/>
-              </a:lnSpc>
-            </a:pPr>
-            <a:r>
-              <a:rPr sz="2300" b="1" i="0">
-                <a:solidFill>
-                  <a:srgbClr val="1C2119"/>
-                </a:solidFill>
-                <a:latin typeface="Calibri"/>
-              </a:rPr>
-              <a:t>Before Trusting the New Data: a Scale Sanity Check</a:t>
-            </a:r>
-          </a:p>
-        </p:txBody>
-      </p:sp>
-      <p:sp>
-        <p:nvSpPr>
-          <p:cNvPr id="4" name="Rectangle 3"/>
-          <p:cNvSpPr/>
-          <p:nvPr/>
-        </p:nvSpPr>
-        <p:spPr>
-          <a:xfrm>
-            <a:off x="502920" y="1261872"/>
-            <a:ext cx="914400" cy="38100"/>
-          </a:xfrm>
-          <a:prstGeom prst="rect">
-            <a:avLst/>
-          </a:prstGeom>
-          <a:solidFill>
-            <a:srgbClr val="2F6F5E"/>
-          </a:solidFill>
-          <a:ln>
-            <a:noFill/>
-          </a:ln>
-          <a:effectLst/>
-        </p:spPr>
-        <p:style>
-          <a:lnRef idx="1">
-            <a:schemeClr val="accent1"/>
-          </a:lnRef>
-          <a:fillRef idx="3">
-            <a:schemeClr val="accent1"/>
-          </a:fillRef>
-          <a:effectRef idx="2">
-            <a:schemeClr val="accent1"/>
-          </a:effectRef>
-          <a:fontRef idx="minor">
-            <a:schemeClr val="lt1"/>
-          </a:fontRef>
-        </p:style>
-        <p:txBody>
-          <a:bodyPr rtlCol="0" anchor="ctr"/>
-          <a:lstStyle/>
-          <a:p>
-            <a:pPr algn="ctr"/>
-          </a:p>
-        </p:txBody>
-      </p:sp>
-      <p:sp>
-        <p:nvSpPr>
-          <p:cNvPr id="5" name="TextBox 4"/>
-          <p:cNvSpPr txBox="1"/>
-          <p:nvPr/>
-        </p:nvSpPr>
-        <p:spPr>
-          <a:xfrm>
-            <a:off x="11551615" y="384048"/>
-            <a:ext cx="365760" cy="274320"/>
-          </a:xfrm>
-          <a:prstGeom prst="rect">
-            <a:avLst/>
-          </a:prstGeom>
-          <a:noFill/>
-        </p:spPr>
-        <p:txBody>
-          <a:bodyPr wrap="square" anchor="t" lIns="0" rIns="0" tIns="0" bIns="0">
-            <a:spAutoFit/>
-          </a:bodyPr>
-          <a:lstStyle/>
-          <a:p>
-            <a:pPr algn="r">
-              <a:lnSpc>
-                <a:spcPct val="100000"/>
-              </a:lnSpc>
-            </a:pPr>
-            <a:r>
-              <a:rPr sz="1100" b="0" i="0">
-                <a:solidFill>
-                  <a:srgbClr val="8B9382"/>
-                </a:solidFill>
-                <a:latin typeface="Calibri"/>
-              </a:rPr>
-              <a:t>6</a:t>
-            </a:r>
-          </a:p>
-        </p:txBody>
-      </p:sp>
-      <p:sp>
-        <p:nvSpPr>
-          <p:cNvPr id="6" name="TextBox 5"/>
-          <p:cNvSpPr txBox="1"/>
-          <p:nvPr/>
-        </p:nvSpPr>
-        <p:spPr>
-          <a:xfrm>
-            <a:off x="502920" y="1143000"/>
-            <a:ext cx="10789920" cy="2377440"/>
-          </a:xfrm>
-          <a:prstGeom prst="rect">
-            <a:avLst/>
-          </a:prstGeom>
-          <a:noFill/>
-        </p:spPr>
-        <p:txBody>
-          <a:bodyPr wrap="square" anchor="t" lIns="0" rIns="0">
-            <a:spAutoFit/>
-          </a:bodyPr>
-          <a:lstStyle/>
-          <a:p>
-            <a:pPr>
-              <a:lnSpc>
-                <a:spcPct val="106000"/>
-              </a:lnSpc>
-              <a:spcAft>
-                <a:spcPts val="1200"/>
-              </a:spcAft>
-            </a:pPr>
-            <a:r>
-              <a:rPr sz="1550">
-                <a:solidFill>
-                  <a:srgbClr val="2F6F5E"/>
-                </a:solidFill>
-                <a:latin typeface="Calibri"/>
-              </a:rPr>
-              <a:t>▪  </a:t>
-            </a:r>
-            <a:r>
-              <a:rPr sz="1550">
-                <a:solidFill>
-                  <a:srgbClr val="1C2119"/>
-                </a:solidFill>
-                <a:latin typeface="Calibri"/>
-              </a:rPr>
-              <a:t>Good-QC Gpp_500m values for forest/grass sites come out in the 0-0.1 kg C/m²/8-day range - looked suspiciously low at first glance, the same kind of place a 10x LAI scale-factor bug hid earlier in this project.</a:t>
-            </a:r>
-          </a:p>
-          <a:p>
-            <a:pPr>
-              <a:lnSpc>
-                <a:spcPct val="106000"/>
-              </a:lnSpc>
-              <a:spcAft>
-                <a:spcPts val="1200"/>
-              </a:spcAft>
-            </a:pPr>
-            <a:r>
-              <a:rPr sz="1550">
-                <a:solidFill>
-                  <a:srgbClr val="2F6F5E"/>
-                </a:solidFill>
-                <a:latin typeface="Calibri"/>
-              </a:rPr>
-              <a:t>▪  </a:t>
-            </a:r>
-            <a:r>
-              <a:rPr sz="1550">
-                <a:solidFill>
-                  <a:srgbClr val="1C2119"/>
-                </a:solidFill>
-                <a:latin typeface="Calibri"/>
-              </a:rPr>
-              <a:t>Summed to an annual total per site instead of eyeballing 8-day values: e.g. px005_trees_bd (broadleaf-deciduous forest) comes out to ~0.9–1.0 kg C/m²/year across 2015–2018.</a:t>
-            </a:r>
-          </a:p>
-          <a:p>
-            <a:pPr>
-              <a:lnSpc>
-                <a:spcPct val="106000"/>
-              </a:lnSpc>
-              <a:spcAft>
-                <a:spcPts val="1200"/>
-              </a:spcAft>
-            </a:pPr>
-            <a:r>
-              <a:rPr sz="1550">
-                <a:solidFill>
-                  <a:srgbClr val="2F6F5E"/>
-                </a:solidFill>
-                <a:latin typeface="Calibri"/>
-              </a:rPr>
-              <a:t>▪  </a:t>
-            </a:r>
-            <a:r>
-              <a:rPr sz="1550">
-                <a:solidFill>
-                  <a:srgbClr val="1C2119"/>
-                </a:solidFill>
-                <a:latin typeface="Calibri"/>
-              </a:rPr>
-              <a:t>This lines up with published typical annual GPP for temperate forest/grassland - confirming the scale factor is correct, not a repeat of the earlier bug.</a:t>
-            </a:r>
-          </a:p>
-        </p:txBody>
-      </p:sp>
-      <p:sp>
-        <p:nvSpPr>
-          <p:cNvPr id="7" name="Rectangle 6"/>
-          <p:cNvSpPr/>
-          <p:nvPr/>
-        </p:nvSpPr>
-        <p:spPr>
-          <a:xfrm>
-            <a:off x="0" y="6144768"/>
-            <a:ext cx="12191695" cy="713232"/>
-          </a:xfrm>
-          <a:prstGeom prst="rect">
-            <a:avLst/>
-          </a:prstGeom>
-          <a:solidFill>
-            <a:srgbClr val="E7F0E6"/>
-          </a:solidFill>
-          <a:ln>
-            <a:noFill/>
-          </a:ln>
-          <a:effectLst/>
-        </p:spPr>
-        <p:style>
-          <a:lnRef idx="1">
-            <a:schemeClr val="accent1"/>
-          </a:lnRef>
-          <a:fillRef idx="3">
-            <a:schemeClr val="accent1"/>
-          </a:fillRef>
-          <a:effectRef idx="2">
-            <a:schemeClr val="accent1"/>
-          </a:effectRef>
-          <a:fontRef idx="minor">
-            <a:schemeClr val="lt1"/>
-          </a:fontRef>
-        </p:style>
-        <p:txBody>
-          <a:bodyPr rtlCol="0" anchor="ctr"/>
-          <a:lstStyle/>
-          <a:p>
-            <a:pPr algn="ctr"/>
-          </a:p>
-        </p:txBody>
-      </p:sp>
-      <p:sp>
-        <p:nvSpPr>
-          <p:cNvPr id="8" name="Rectangle 7"/>
-          <p:cNvSpPr/>
-          <p:nvPr/>
-        </p:nvSpPr>
-        <p:spPr>
-          <a:xfrm>
-            <a:off x="0" y="6144768"/>
-            <a:ext cx="109728" cy="713232"/>
-          </a:xfrm>
-          <a:prstGeom prst="rect">
-            <a:avLst/>
-          </a:prstGeom>
-          <a:solidFill>
-            <a:srgbClr val="2F6F5E"/>
-          </a:solidFill>
-          <a:ln>
-            <a:noFill/>
-          </a:ln>
-          <a:effectLst/>
-        </p:spPr>
-        <p:style>
-          <a:lnRef idx="1">
-            <a:schemeClr val="accent1"/>
-          </a:lnRef>
-          <a:fillRef idx="3">
-            <a:schemeClr val="accent1"/>
-          </a:fillRef>
-          <a:effectRef idx="2">
-            <a:schemeClr val="accent1"/>
-          </a:effectRef>
-          <a:fontRef idx="minor">
-            <a:schemeClr val="lt1"/>
-          </a:fontRef>
-        </p:style>
-        <p:txBody>
-          <a:bodyPr rtlCol="0" anchor="ctr"/>
-          <a:lstStyle/>
-          <a:p>
-            <a:pPr algn="ctr"/>
-          </a:p>
-        </p:txBody>
-      </p:sp>
-      <p:sp>
-        <p:nvSpPr>
-          <p:cNvPr id="9" name="TextBox 8"/>
-          <p:cNvSpPr txBox="1"/>
-          <p:nvPr/>
-        </p:nvSpPr>
-        <p:spPr>
-          <a:xfrm>
-            <a:off x="411480" y="6144768"/>
-            <a:ext cx="11368735" cy="713232"/>
-          </a:xfrm>
-          <a:prstGeom prst="rect">
-            <a:avLst/>
-          </a:prstGeom>
-          <a:noFill/>
-        </p:spPr>
-        <p:txBody>
-          <a:bodyPr wrap="square" anchor="ctr" lIns="0" rIns="0" tIns="0" bIns="0">
-            <a:spAutoFit/>
-          </a:bodyPr>
-          <a:lstStyle/>
-          <a:p>
-            <a:pPr algn="l">
-              <a:lnSpc>
-                <a:spcPct val="100000"/>
-              </a:lnSpc>
-            </a:pPr>
-            <a:r>
-              <a:rPr sz="1200" b="1" i="0">
-                <a:solidFill>
-                  <a:srgbClr val="1E4A33"/>
-                </a:solidFill>
-                <a:latin typeface="Calibri"/>
-              </a:rPr>
-              <a:t>TAKEAWAY   </a:t>
-            </a:r>
-          </a:p>
-        </p:txBody>
-      </p:sp>
-      <p:sp>
-        <p:nvSpPr>
-          <p:cNvPr id="10" name="TextBox 9"/>
-          <p:cNvSpPr txBox="1"/>
-          <p:nvPr/>
-        </p:nvSpPr>
-        <p:spPr>
-          <a:xfrm>
-            <a:off x="1417320" y="6144768"/>
-            <a:ext cx="10362895" cy="713232"/>
-          </a:xfrm>
-          <a:prstGeom prst="rect">
-            <a:avLst/>
-          </a:prstGeom>
-          <a:noFill/>
-        </p:spPr>
-        <p:txBody>
-          <a:bodyPr wrap="square" anchor="ctr" lIns="0" rIns="0" tIns="0" bIns="0">
-            <a:spAutoFit/>
-          </a:bodyPr>
-          <a:lstStyle/>
-          <a:p>
-            <a:pPr algn="l">
-              <a:lnSpc>
-                <a:spcPct val="100000"/>
-              </a:lnSpc>
-            </a:pPr>
-            <a:r>
-              <a:rPr sz="1450" b="1" i="0">
-                <a:solidFill>
-                  <a:srgbClr val="1E4A33"/>
-                </a:solidFill>
-                <a:latin typeface="Calibri"/>
-              </a:rPr>
-              <a:t>Verified empirically before using the data, rather than assuming either way.</a:t>
-            </a:r>
-          </a:p>
-        </p:txBody>
-      </p:sp>
-    </p:spTree>
-  </p:cSld>
-  <p:clrMapOvr>
-    <a:masterClrMapping/>
-  </p:clrMapOvr>
-</p:sld>
-</file>
-
 <file path=ppt/slides/slide7.xml><?xml version="1.0" encoding="utf-8"?>
 <p:sld xmlns:a="http://schemas.openxmlformats.org/drawingml/2006/main" xmlns:p="http://schemas.openxmlformats.org/presentationml/2006/main" xmlns:r="http://schemas.openxmlformats.org/officeDocument/2006/relationships">
   <p:cSld>
@@ -6148,7 +6577,7 @@
                 </a:solidFill>
                 <a:latin typeface="Calibri"/>
               </a:rPr>
-              <a:t>PART 3 — GPP vs. LAI, ZERO-SHOT</a:t>
+              <a:t>PART 2 — GPP DATA FIX</a:t>
             </a:r>
           </a:p>
         </p:txBody>
@@ -6187,7 +6616,7 @@
                 </a:solidFill>
                 <a:latin typeface="Calibri"/>
               </a:rPr>
-              <a:t>Part 3: First Zero-Shot GPP vs. LAI Comparison</a:t>
+              <a:t>Before Trusting the New Data: a Scale Sanity Check</a:t>
             </a:r>
           </a:p>
         </p:txBody>
@@ -6271,6 +6700,466 @@
                 <a:latin typeface="Calibri"/>
               </a:rPr>
               <a:t>7</a:t>
+            </a:r>
+          </a:p>
+        </p:txBody>
+      </p:sp>
+      <p:sp>
+        <p:nvSpPr>
+          <p:cNvPr id="6" name="TextBox 5"/>
+          <p:cNvSpPr txBox="1"/>
+          <p:nvPr/>
+        </p:nvSpPr>
+        <p:spPr>
+          <a:xfrm>
+            <a:off x="502920" y="1143000"/>
+            <a:ext cx="10789920" cy="2377440"/>
+          </a:xfrm>
+          <a:prstGeom prst="rect">
+            <a:avLst/>
+          </a:prstGeom>
+          <a:noFill/>
+        </p:spPr>
+        <p:txBody>
+          <a:bodyPr wrap="square" anchor="t" lIns="0" rIns="0">
+            <a:spAutoFit/>
+          </a:bodyPr>
+          <a:lstStyle/>
+          <a:p>
+            <a:pPr>
+              <a:lnSpc>
+                <a:spcPct val="106000"/>
+              </a:lnSpc>
+              <a:spcAft>
+                <a:spcPts val="1200"/>
+              </a:spcAft>
+            </a:pPr>
+            <a:r>
+              <a:rPr sz="1550">
+                <a:solidFill>
+                  <a:srgbClr val="2F6F5E"/>
+                </a:solidFill>
+                <a:latin typeface="Calibri"/>
+              </a:rPr>
+              <a:t>▪  </a:t>
+            </a:r>
+            <a:r>
+              <a:rPr sz="1550">
+                <a:solidFill>
+                  <a:srgbClr val="1C2119"/>
+                </a:solidFill>
+                <a:latin typeface="Calibri"/>
+              </a:rPr>
+              <a:t>Good-QC Gpp_500m values for forest/grass sites come out in the 0-0.1 kg C/m²/8-day range - looked suspiciously low at first glance, the same kind of place a 10x LAI scale-factor bug hid earlier in this project.</a:t>
+            </a:r>
+          </a:p>
+          <a:p>
+            <a:pPr>
+              <a:lnSpc>
+                <a:spcPct val="106000"/>
+              </a:lnSpc>
+              <a:spcAft>
+                <a:spcPts val="1200"/>
+              </a:spcAft>
+            </a:pPr>
+            <a:r>
+              <a:rPr sz="1550">
+                <a:solidFill>
+                  <a:srgbClr val="2F6F5E"/>
+                </a:solidFill>
+                <a:latin typeface="Calibri"/>
+              </a:rPr>
+              <a:t>▪  </a:t>
+            </a:r>
+            <a:r>
+              <a:rPr sz="1550">
+                <a:solidFill>
+                  <a:srgbClr val="1C2119"/>
+                </a:solidFill>
+                <a:latin typeface="Calibri"/>
+              </a:rPr>
+              <a:t>Summed to an annual total per site instead of eyeballing 8-day values: e.g. px005_trees_bd (broadleaf-deciduous forest) comes out to ~0.9–1.0 kg C/m²/year across 2015–2018.</a:t>
+            </a:r>
+          </a:p>
+          <a:p>
+            <a:pPr>
+              <a:lnSpc>
+                <a:spcPct val="106000"/>
+              </a:lnSpc>
+              <a:spcAft>
+                <a:spcPts val="1200"/>
+              </a:spcAft>
+            </a:pPr>
+            <a:r>
+              <a:rPr sz="1550">
+                <a:solidFill>
+                  <a:srgbClr val="2F6F5E"/>
+                </a:solidFill>
+                <a:latin typeface="Calibri"/>
+              </a:rPr>
+              <a:t>▪  </a:t>
+            </a:r>
+            <a:r>
+              <a:rPr sz="1550">
+                <a:solidFill>
+                  <a:srgbClr val="1C2119"/>
+                </a:solidFill>
+                <a:latin typeface="Calibri"/>
+              </a:rPr>
+              <a:t>This lines up with published typical annual GPP for temperate forest/grassland - confirming the scale factor is correct, not a repeat of the earlier bug.</a:t>
+            </a:r>
+          </a:p>
+        </p:txBody>
+      </p:sp>
+      <p:sp>
+        <p:nvSpPr>
+          <p:cNvPr id="7" name="Rectangle 6"/>
+          <p:cNvSpPr/>
+          <p:nvPr/>
+        </p:nvSpPr>
+        <p:spPr>
+          <a:xfrm>
+            <a:off x="0" y="6144768"/>
+            <a:ext cx="12191695" cy="713232"/>
+          </a:xfrm>
+          <a:prstGeom prst="rect">
+            <a:avLst/>
+          </a:prstGeom>
+          <a:solidFill>
+            <a:srgbClr val="E7F0E6"/>
+          </a:solidFill>
+          <a:ln>
+            <a:noFill/>
+          </a:ln>
+          <a:effectLst/>
+        </p:spPr>
+        <p:style>
+          <a:lnRef idx="1">
+            <a:schemeClr val="accent1"/>
+          </a:lnRef>
+          <a:fillRef idx="3">
+            <a:schemeClr val="accent1"/>
+          </a:fillRef>
+          <a:effectRef idx="2">
+            <a:schemeClr val="accent1"/>
+          </a:effectRef>
+          <a:fontRef idx="minor">
+            <a:schemeClr val="lt1"/>
+          </a:fontRef>
+        </p:style>
+        <p:txBody>
+          <a:bodyPr rtlCol="0" anchor="ctr"/>
+          <a:lstStyle/>
+          <a:p>
+            <a:pPr algn="ctr"/>
+          </a:p>
+        </p:txBody>
+      </p:sp>
+      <p:sp>
+        <p:nvSpPr>
+          <p:cNvPr id="8" name="Rectangle 7"/>
+          <p:cNvSpPr/>
+          <p:nvPr/>
+        </p:nvSpPr>
+        <p:spPr>
+          <a:xfrm>
+            <a:off x="0" y="6144768"/>
+            <a:ext cx="109728" cy="713232"/>
+          </a:xfrm>
+          <a:prstGeom prst="rect">
+            <a:avLst/>
+          </a:prstGeom>
+          <a:solidFill>
+            <a:srgbClr val="2F6F5E"/>
+          </a:solidFill>
+          <a:ln>
+            <a:noFill/>
+          </a:ln>
+          <a:effectLst/>
+        </p:spPr>
+        <p:style>
+          <a:lnRef idx="1">
+            <a:schemeClr val="accent1"/>
+          </a:lnRef>
+          <a:fillRef idx="3">
+            <a:schemeClr val="accent1"/>
+          </a:fillRef>
+          <a:effectRef idx="2">
+            <a:schemeClr val="accent1"/>
+          </a:effectRef>
+          <a:fontRef idx="minor">
+            <a:schemeClr val="lt1"/>
+          </a:fontRef>
+        </p:style>
+        <p:txBody>
+          <a:bodyPr rtlCol="0" anchor="ctr"/>
+          <a:lstStyle/>
+          <a:p>
+            <a:pPr algn="ctr"/>
+          </a:p>
+        </p:txBody>
+      </p:sp>
+      <p:sp>
+        <p:nvSpPr>
+          <p:cNvPr id="9" name="TextBox 8"/>
+          <p:cNvSpPr txBox="1"/>
+          <p:nvPr/>
+        </p:nvSpPr>
+        <p:spPr>
+          <a:xfrm>
+            <a:off x="411480" y="6144768"/>
+            <a:ext cx="11368735" cy="713232"/>
+          </a:xfrm>
+          <a:prstGeom prst="rect">
+            <a:avLst/>
+          </a:prstGeom>
+          <a:noFill/>
+        </p:spPr>
+        <p:txBody>
+          <a:bodyPr wrap="square" anchor="ctr" lIns="0" rIns="0" tIns="0" bIns="0">
+            <a:spAutoFit/>
+          </a:bodyPr>
+          <a:lstStyle/>
+          <a:p>
+            <a:pPr algn="l">
+              <a:lnSpc>
+                <a:spcPct val="100000"/>
+              </a:lnSpc>
+            </a:pPr>
+            <a:r>
+              <a:rPr sz="1200" b="1" i="0">
+                <a:solidFill>
+                  <a:srgbClr val="1E4A33"/>
+                </a:solidFill>
+                <a:latin typeface="Calibri"/>
+              </a:rPr>
+              <a:t>TAKEAWAY   </a:t>
+            </a:r>
+          </a:p>
+        </p:txBody>
+      </p:sp>
+      <p:sp>
+        <p:nvSpPr>
+          <p:cNvPr id="10" name="TextBox 9"/>
+          <p:cNvSpPr txBox="1"/>
+          <p:nvPr/>
+        </p:nvSpPr>
+        <p:spPr>
+          <a:xfrm>
+            <a:off x="1417320" y="6144768"/>
+            <a:ext cx="10362895" cy="713232"/>
+          </a:xfrm>
+          <a:prstGeom prst="rect">
+            <a:avLst/>
+          </a:prstGeom>
+          <a:noFill/>
+        </p:spPr>
+        <p:txBody>
+          <a:bodyPr wrap="square" anchor="ctr" lIns="0" rIns="0" tIns="0" bIns="0">
+            <a:spAutoFit/>
+          </a:bodyPr>
+          <a:lstStyle/>
+          <a:p>
+            <a:pPr algn="l">
+              <a:lnSpc>
+                <a:spcPct val="100000"/>
+              </a:lnSpc>
+            </a:pPr>
+            <a:r>
+              <a:rPr sz="1450" b="1" i="0">
+                <a:solidFill>
+                  <a:srgbClr val="1E4A33"/>
+                </a:solidFill>
+                <a:latin typeface="Calibri"/>
+              </a:rPr>
+              <a:t>Verified empirically before using the data, rather than assuming either way.</a:t>
+            </a:r>
+          </a:p>
+        </p:txBody>
+      </p:sp>
+    </p:spTree>
+  </p:cSld>
+  <p:clrMapOvr>
+    <a:masterClrMapping/>
+  </p:clrMapOvr>
+</p:sld>
+</file>
+
+<file path=ppt/slides/slide8.xml><?xml version="1.0" encoding="utf-8"?>
+<p:sld xmlns:a="http://schemas.openxmlformats.org/drawingml/2006/main" xmlns:p="http://schemas.openxmlformats.org/presentationml/2006/main" xmlns:r="http://schemas.openxmlformats.org/officeDocument/2006/relationships">
+  <p:cSld>
+    <p:bg>
+      <p:bgPr>
+        <a:solidFill>
+          <a:srgbClr val="FFFFFF"/>
+        </a:solidFill>
+        <a:effectLst/>
+      </p:bgPr>
+    </p:bg>
+    <p:spTree>
+      <p:nvGrpSpPr>
+        <p:cNvPr id="1" name=""/>
+        <p:cNvGrpSpPr/>
+        <p:nvPr/>
+      </p:nvGrpSpPr>
+      <p:grpSpPr/>
+      <p:sp>
+        <p:nvSpPr>
+          <p:cNvPr id="2" name="TextBox 1"/>
+          <p:cNvSpPr txBox="1"/>
+          <p:nvPr/>
+        </p:nvSpPr>
+        <p:spPr>
+          <a:xfrm>
+            <a:off x="502920" y="384048"/>
+            <a:ext cx="10972800" cy="292608"/>
+          </a:xfrm>
+          <a:prstGeom prst="rect">
+            <a:avLst/>
+          </a:prstGeom>
+          <a:noFill/>
+        </p:spPr>
+        <p:txBody>
+          <a:bodyPr wrap="square" anchor="t" lIns="0" rIns="0" tIns="0" bIns="0">
+            <a:spAutoFit/>
+          </a:bodyPr>
+          <a:lstStyle/>
+          <a:p>
+            <a:pPr algn="l">
+              <a:lnSpc>
+                <a:spcPct val="100000"/>
+              </a:lnSpc>
+            </a:pPr>
+            <a:r>
+              <a:rPr sz="1300" b="1" i="0">
+                <a:solidFill>
+                  <a:srgbClr val="2F6F5E"/>
+                </a:solidFill>
+                <a:latin typeface="Calibri"/>
+              </a:rPr>
+              <a:t>PART 3 — GPP vs. LAI, ZERO-SHOT</a:t>
+            </a:r>
+          </a:p>
+        </p:txBody>
+      </p:sp>
+      <p:sp>
+        <p:nvSpPr>
+          <p:cNvPr id="3" name="TextBox 2"/>
+          <p:cNvSpPr txBox="1"/>
+          <p:nvPr/>
+        </p:nvSpPr>
+        <p:spPr>
+          <a:xfrm>
+            <a:off x="502920" y="658368"/>
+            <a:ext cx="11155680" cy="566928"/>
+          </a:xfrm>
+          <a:prstGeom prst="rect">
+            <a:avLst/>
+          </a:prstGeom>
+          <a:noFill/>
+        </p:spPr>
+        <p:txBody>
+          <a:bodyPr wrap="square" anchor="t" lIns="0" rIns="0" tIns="0" bIns="0">
+            <a:spAutoFit/>
+          </a:bodyPr>
+          <a:lstStyle/>
+          <a:p>
+            <a:pPr algn="l">
+              <a:lnSpc>
+                <a:spcPct val="100000"/>
+              </a:lnSpc>
+            </a:pPr>
+            <a:r>
+              <a:rPr sz="2300" b="1" i="0">
+                <a:solidFill>
+                  <a:srgbClr val="1C2119"/>
+                </a:solidFill>
+                <a:latin typeface="Calibri"/>
+              </a:rPr>
+              <a:t>Part 3: First Zero-Shot GPP vs. LAI Comparison</a:t>
+            </a:r>
+          </a:p>
+        </p:txBody>
+      </p:sp>
+      <p:sp>
+        <p:nvSpPr>
+          <p:cNvPr id="4" name="Rectangle 3"/>
+          <p:cNvSpPr/>
+          <p:nvPr/>
+        </p:nvSpPr>
+        <p:spPr>
+          <a:xfrm>
+            <a:off x="502920" y="1261872"/>
+            <a:ext cx="914400" cy="38100"/>
+          </a:xfrm>
+          <a:prstGeom prst="rect">
+            <a:avLst/>
+          </a:prstGeom>
+          <a:solidFill>
+            <a:srgbClr val="2F6F5E"/>
+          </a:solidFill>
+          <a:ln>
+            <a:noFill/>
+          </a:ln>
+          <a:effectLst/>
+        </p:spPr>
+        <p:style>
+          <a:lnRef idx="1">
+            <a:schemeClr val="accent1"/>
+          </a:lnRef>
+          <a:fillRef idx="3">
+            <a:schemeClr val="accent1"/>
+          </a:fillRef>
+          <a:effectRef idx="2">
+            <a:schemeClr val="accent1"/>
+          </a:effectRef>
+          <a:fontRef idx="minor">
+            <a:schemeClr val="lt1"/>
+          </a:fontRef>
+        </p:style>
+        <p:txBody>
+          <a:bodyPr rtlCol="0" anchor="ctr"/>
+          <a:lstStyle/>
+          <a:p>
+            <a:pPr algn="ctr"/>
+          </a:p>
+        </p:txBody>
+      </p:sp>
+      <p:sp>
+        <p:nvSpPr>
+          <p:cNvPr id="5" name="TextBox 4"/>
+          <p:cNvSpPr txBox="1"/>
+          <p:nvPr/>
+        </p:nvSpPr>
+        <p:spPr>
+          <a:xfrm>
+            <a:off x="11551615" y="384048"/>
+            <a:ext cx="365760" cy="274320"/>
+          </a:xfrm>
+          <a:prstGeom prst="rect">
+            <a:avLst/>
+          </a:prstGeom>
+          <a:noFill/>
+        </p:spPr>
+        <p:txBody>
+          <a:bodyPr wrap="square" anchor="t" lIns="0" rIns="0" tIns="0" bIns="0">
+            <a:spAutoFit/>
+          </a:bodyPr>
+          <a:lstStyle/>
+          <a:p>
+            <a:pPr algn="r">
+              <a:lnSpc>
+                <a:spcPct val="100000"/>
+              </a:lnSpc>
+            </a:pPr>
+            <a:r>
+              <a:rPr sz="1100" b="0" i="0">
+                <a:solidFill>
+                  <a:srgbClr val="8B9382"/>
+                </a:solidFill>
+                <a:latin typeface="Calibri"/>
+              </a:rPr>
+              <a:t>8</a:t>
             </a:r>
           </a:p>
         </p:txBody>
@@ -6880,7 +7769,7 @@
 </p:sld>
 </file>
 
-<file path=ppt/slides/slide8.xml><?xml version="1.0" encoding="utf-8"?>
+<file path=ppt/slides/slide9.xml><?xml version="1.0" encoding="utf-8"?>
 <p:sld xmlns:a="http://schemas.openxmlformats.org/drawingml/2006/main" xmlns:p="http://schemas.openxmlformats.org/presentationml/2006/main" xmlns:r="http://schemas.openxmlformats.org/officeDocument/2006/relationships">
   <p:cSld>
     <p:bg>
@@ -7054,7 +7943,7 @@
                 </a:solidFill>
                 <a:latin typeface="Calibri"/>
               </a:rPr>
-              <a:t>8</a:t>
+              <a:t>9</a:t>
             </a:r>
           </a:p>
         </p:txBody>
@@ -8107,517 +8996,6 @@
 </p:sld>
 </file>
 
-<file path=ppt/slides/slide9.xml><?xml version="1.0" encoding="utf-8"?>
-<p:sld xmlns:a="http://schemas.openxmlformats.org/drawingml/2006/main" xmlns:p="http://schemas.openxmlformats.org/presentationml/2006/main" xmlns:r="http://schemas.openxmlformats.org/officeDocument/2006/relationships">
-  <p:cSld>
-    <p:bg>
-      <p:bgPr>
-        <a:solidFill>
-          <a:srgbClr val="FFFFFF"/>
-        </a:solidFill>
-        <a:effectLst/>
-      </p:bgPr>
-    </p:bg>
-    <p:spTree>
-      <p:nvGrpSpPr>
-        <p:cNvPr id="1" name=""/>
-        <p:cNvGrpSpPr/>
-        <p:nvPr/>
-      </p:nvGrpSpPr>
-      <p:grpSpPr/>
-      <p:sp>
-        <p:nvSpPr>
-          <p:cNvPr id="2" name="TextBox 1"/>
-          <p:cNvSpPr txBox="1"/>
-          <p:nvPr/>
-        </p:nvSpPr>
-        <p:spPr>
-          <a:xfrm>
-            <a:off x="502920" y="384048"/>
-            <a:ext cx="10972800" cy="292608"/>
-          </a:xfrm>
-          <a:prstGeom prst="rect">
-            <a:avLst/>
-          </a:prstGeom>
-          <a:noFill/>
-        </p:spPr>
-        <p:txBody>
-          <a:bodyPr wrap="square" anchor="t" lIns="0" rIns="0" tIns="0" bIns="0">
-            <a:spAutoFit/>
-          </a:bodyPr>
-          <a:lstStyle/>
-          <a:p>
-            <a:pPr algn="l">
-              <a:lnSpc>
-                <a:spcPct val="100000"/>
-              </a:lnSpc>
-            </a:pPr>
-            <a:r>
-              <a:rPr sz="1300" b="1" i="0">
-                <a:solidFill>
-                  <a:srgbClr val="2F6F5E"/>
-                </a:solidFill>
-                <a:latin typeface="Calibri"/>
-              </a:rPr>
-              <a:t>NEXT STEPS</a:t>
-            </a:r>
-          </a:p>
-        </p:txBody>
-      </p:sp>
-      <p:sp>
-        <p:nvSpPr>
-          <p:cNvPr id="3" name="TextBox 2"/>
-          <p:cNvSpPr txBox="1"/>
-          <p:nvPr/>
-        </p:nvSpPr>
-        <p:spPr>
-          <a:xfrm>
-            <a:off x="502920" y="658368"/>
-            <a:ext cx="11155680" cy="566928"/>
-          </a:xfrm>
-          <a:prstGeom prst="rect">
-            <a:avLst/>
-          </a:prstGeom>
-          <a:noFill/>
-        </p:spPr>
-        <p:txBody>
-          <a:bodyPr wrap="square" anchor="t" lIns="0" rIns="0" tIns="0" bIns="0">
-            <a:spAutoFit/>
-          </a:bodyPr>
-          <a:lstStyle/>
-          <a:p>
-            <a:pPr algn="l">
-              <a:lnSpc>
-                <a:spcPct val="100000"/>
-              </a:lnSpc>
-            </a:pPr>
-            <a:r>
-              <a:rPr sz="2300" b="1" i="0">
-                <a:solidFill>
-                  <a:srgbClr val="1C2119"/>
-                </a:solidFill>
-                <a:latin typeface="Calibri"/>
-              </a:rPr>
-              <a:t>Interpretation and Next Steps</a:t>
-            </a:r>
-          </a:p>
-        </p:txBody>
-      </p:sp>
-      <p:sp>
-        <p:nvSpPr>
-          <p:cNvPr id="4" name="Rectangle 3"/>
-          <p:cNvSpPr/>
-          <p:nvPr/>
-        </p:nvSpPr>
-        <p:spPr>
-          <a:xfrm>
-            <a:off x="502920" y="1261872"/>
-            <a:ext cx="914400" cy="38100"/>
-          </a:xfrm>
-          <a:prstGeom prst="rect">
-            <a:avLst/>
-          </a:prstGeom>
-          <a:solidFill>
-            <a:srgbClr val="2F6F5E"/>
-          </a:solidFill>
-          <a:ln>
-            <a:noFill/>
-          </a:ln>
-          <a:effectLst/>
-        </p:spPr>
-        <p:style>
-          <a:lnRef idx="1">
-            <a:schemeClr val="accent1"/>
-          </a:lnRef>
-          <a:fillRef idx="3">
-            <a:schemeClr val="accent1"/>
-          </a:fillRef>
-          <a:effectRef idx="2">
-            <a:schemeClr val="accent1"/>
-          </a:effectRef>
-          <a:fontRef idx="minor">
-            <a:schemeClr val="lt1"/>
-          </a:fontRef>
-        </p:style>
-        <p:txBody>
-          <a:bodyPr rtlCol="0" anchor="ctr"/>
-          <a:lstStyle/>
-          <a:p>
-            <a:pPr algn="ctr"/>
-          </a:p>
-        </p:txBody>
-      </p:sp>
-      <p:sp>
-        <p:nvSpPr>
-          <p:cNvPr id="5" name="TextBox 4"/>
-          <p:cNvSpPr txBox="1"/>
-          <p:nvPr/>
-        </p:nvSpPr>
-        <p:spPr>
-          <a:xfrm>
-            <a:off x="11551615" y="384048"/>
-            <a:ext cx="365760" cy="274320"/>
-          </a:xfrm>
-          <a:prstGeom prst="rect">
-            <a:avLst/>
-          </a:prstGeom>
-          <a:noFill/>
-        </p:spPr>
-        <p:txBody>
-          <a:bodyPr wrap="square" anchor="t" lIns="0" rIns="0" tIns="0" bIns="0">
-            <a:spAutoFit/>
-          </a:bodyPr>
-          <a:lstStyle/>
-          <a:p>
-            <a:pPr algn="r">
-              <a:lnSpc>
-                <a:spcPct val="100000"/>
-              </a:lnSpc>
-            </a:pPr>
-            <a:r>
-              <a:rPr sz="1100" b="0" i="0">
-                <a:solidFill>
-                  <a:srgbClr val="8B9382"/>
-                </a:solidFill>
-                <a:latin typeface="Calibri"/>
-              </a:rPr>
-              <a:t>9</a:t>
-            </a:r>
-          </a:p>
-        </p:txBody>
-      </p:sp>
-      <p:sp>
-        <p:nvSpPr>
-          <p:cNvPr id="6" name="TextBox 5"/>
-          <p:cNvSpPr txBox="1"/>
-          <p:nvPr/>
-        </p:nvSpPr>
-        <p:spPr>
-          <a:xfrm>
-            <a:off x="502920" y="1143000"/>
-            <a:ext cx="10789920" cy="2377440"/>
-          </a:xfrm>
-          <a:prstGeom prst="rect">
-            <a:avLst/>
-          </a:prstGeom>
-          <a:noFill/>
-        </p:spPr>
-        <p:txBody>
-          <a:bodyPr wrap="square" anchor="t" lIns="0" rIns="0">
-            <a:spAutoFit/>
-          </a:bodyPr>
-          <a:lstStyle/>
-          <a:p>
-            <a:pPr>
-              <a:lnSpc>
-                <a:spcPct val="106000"/>
-              </a:lnSpc>
-              <a:spcAft>
-                <a:spcPts val="1200"/>
-              </a:spcAft>
-            </a:pPr>
-            <a:r>
-              <a:rPr sz="1550">
-                <a:solidFill>
-                  <a:srgbClr val="2F6F5E"/>
-                </a:solidFill>
-                <a:latin typeface="Calibri"/>
-              </a:rPr>
-              <a:t>▪  </a:t>
-            </a:r>
-            <a:r>
-              <a:rPr sz="1550">
-                <a:solidFill>
-                  <a:srgbClr val="1C2119"/>
-                </a:solidFill>
-                <a:latin typeface="Calibri"/>
-              </a:rPr>
-              <a:t>Consistent with Prof. Wang's expectation that GPP is the more weather-coupled, more directly forecastable target - GPP responds to the same short-term weather drivers Chronos-2 sees in its covariates more directly than LAI, which is a slower-integrating structural/canopy variable. (Interpretation - not yet tested directly.)</a:t>
-            </a:r>
-          </a:p>
-          <a:p>
-            <a:pPr>
-              <a:lnSpc>
-                <a:spcPct val="106000"/>
-              </a:lnSpc>
-              <a:spcAft>
-                <a:spcPts val="1200"/>
-              </a:spcAft>
-            </a:pPr>
-            <a:r>
-              <a:rPr sz="1550">
-                <a:solidFill>
-                  <a:srgbClr val="2F6F5E"/>
-                </a:solidFill>
-                <a:latin typeface="Calibri"/>
-              </a:rPr>
-              <a:t>▪  </a:t>
-            </a:r>
-            <a:r>
-              <a:rPr sz="1550">
-                <a:solidFill>
-                  <a:srgbClr val="1C2119"/>
-                </a:solidFill>
-                <a:latin typeface="Calibri"/>
-              </a:rPr>
-              <a:t>This zero-shot result does not yet test whether physics-guided fine-tuning helps GPP more than LAI - it only establishes that the baseline gap between the two targets is real and goes in the expected direction, before spending effort on the fine-tuning comparison.</a:t>
-            </a:r>
-          </a:p>
-        </p:txBody>
-      </p:sp>
-      <p:sp>
-        <p:nvSpPr>
-          <p:cNvPr id="7" name="TextBox 6"/>
-          <p:cNvSpPr txBox="1"/>
-          <p:nvPr/>
-        </p:nvSpPr>
-        <p:spPr>
-          <a:xfrm>
-            <a:off x="502920" y="3611880"/>
-            <a:ext cx="10789920" cy="1645920"/>
-          </a:xfrm>
-          <a:prstGeom prst="rect">
-            <a:avLst/>
-          </a:prstGeom>
-          <a:noFill/>
-        </p:spPr>
-        <p:txBody>
-          <a:bodyPr wrap="square" anchor="t" lIns="0" rIns="0">
-            <a:spAutoFit/>
-          </a:bodyPr>
-          <a:lstStyle/>
-          <a:p>
-            <a:pPr>
-              <a:lnSpc>
-                <a:spcPct val="106000"/>
-              </a:lnSpc>
-              <a:spcAft>
-                <a:spcPts val="1000"/>
-              </a:spcAft>
-            </a:pPr>
-            <a:r>
-              <a:rPr sz="1550">
-                <a:solidFill>
-                  <a:srgbClr val="2A78D6"/>
-                </a:solidFill>
-                <a:latin typeface="Calibri"/>
-              </a:rPr>
-              <a:t>▪  </a:t>
-            </a:r>
-            <a:r>
-              <a:rPr sz="1550">
-                <a:solidFill>
-                  <a:srgbClr val="1C2119"/>
-                </a:solidFill>
-                <a:latin typeface="Calibri"/>
-              </a:rPr>
-              <a:t>Next: confirm this result holds at the full 70-site scale (download in progress on AppEEARS).</a:t>
-            </a:r>
-          </a:p>
-          <a:p>
-            <a:pPr>
-              <a:lnSpc>
-                <a:spcPct val="106000"/>
-              </a:lnSpc>
-              <a:spcAft>
-                <a:spcPts val="1000"/>
-              </a:spcAft>
-            </a:pPr>
-            <a:r>
-              <a:rPr sz="1550">
-                <a:solidFill>
-                  <a:srgbClr val="2A78D6"/>
-                </a:solidFill>
-                <a:latin typeface="Calibri"/>
-              </a:rPr>
-              <a:t>▪  </a:t>
-            </a:r>
-            <a:r>
-              <a:rPr sz="1550">
-                <a:solidFill>
-                  <a:srgbClr val="1C2119"/>
-                </a:solidFill>
-                <a:latin typeface="Calibri"/>
-              </a:rPr>
-              <a:t>Then: physics-guided fine-tuning on GPP, using the existing phenology equation and fine-tuning machinery (already supports GPP as --target-col) - deliberately not started yet, per the agreed order of work.</a:t>
-            </a:r>
-          </a:p>
-        </p:txBody>
-      </p:sp>
-      <p:sp>
-        <p:nvSpPr>
-          <p:cNvPr id="8" name="Rectangle 7"/>
-          <p:cNvSpPr/>
-          <p:nvPr/>
-        </p:nvSpPr>
-        <p:spPr>
-          <a:xfrm>
-            <a:off x="0" y="6144768"/>
-            <a:ext cx="12191695" cy="713232"/>
-          </a:xfrm>
-          <a:prstGeom prst="rect">
-            <a:avLst/>
-          </a:prstGeom>
-          <a:solidFill>
-            <a:srgbClr val="E2ECFA"/>
-          </a:solidFill>
-          <a:ln>
-            <a:noFill/>
-          </a:ln>
-          <a:effectLst/>
-        </p:spPr>
-        <p:style>
-          <a:lnRef idx="1">
-            <a:schemeClr val="accent1"/>
-          </a:lnRef>
-          <a:fillRef idx="3">
-            <a:schemeClr val="accent1"/>
-          </a:fillRef>
-          <a:effectRef idx="2">
-            <a:schemeClr val="accent1"/>
-          </a:effectRef>
-          <a:fontRef idx="minor">
-            <a:schemeClr val="lt1"/>
-          </a:fontRef>
-        </p:style>
-        <p:txBody>
-          <a:bodyPr rtlCol="0" anchor="ctr"/>
-          <a:lstStyle/>
-          <a:p>
-            <a:pPr algn="ctr"/>
-          </a:p>
-        </p:txBody>
-      </p:sp>
-      <p:sp>
-        <p:nvSpPr>
-          <p:cNvPr id="9" name="Rectangle 8"/>
-          <p:cNvSpPr/>
-          <p:nvPr/>
-        </p:nvSpPr>
-        <p:spPr>
-          <a:xfrm>
-            <a:off x="0" y="6144768"/>
-            <a:ext cx="109728" cy="713232"/>
-          </a:xfrm>
-          <a:prstGeom prst="rect">
-            <a:avLst/>
-          </a:prstGeom>
-          <a:solidFill>
-            <a:srgbClr val="2A78D6"/>
-          </a:solidFill>
-          <a:ln>
-            <a:noFill/>
-          </a:ln>
-          <a:effectLst/>
-        </p:spPr>
-        <p:style>
-          <a:lnRef idx="1">
-            <a:schemeClr val="accent1"/>
-          </a:lnRef>
-          <a:fillRef idx="3">
-            <a:schemeClr val="accent1"/>
-          </a:fillRef>
-          <a:effectRef idx="2">
-            <a:schemeClr val="accent1"/>
-          </a:effectRef>
-          <a:fontRef idx="minor">
-            <a:schemeClr val="lt1"/>
-          </a:fontRef>
-        </p:style>
-        <p:txBody>
-          <a:bodyPr rtlCol="0" anchor="ctr"/>
-          <a:lstStyle/>
-          <a:p>
-            <a:pPr algn="ctr"/>
-          </a:p>
-        </p:txBody>
-      </p:sp>
-      <p:sp>
-        <p:nvSpPr>
-          <p:cNvPr id="10" name="TextBox 9"/>
-          <p:cNvSpPr txBox="1"/>
-          <p:nvPr/>
-        </p:nvSpPr>
-        <p:spPr>
-          <a:xfrm>
-            <a:off x="411480" y="6144768"/>
-            <a:ext cx="11368735" cy="713232"/>
-          </a:xfrm>
-          <a:prstGeom prst="rect">
-            <a:avLst/>
-          </a:prstGeom>
-          <a:noFill/>
-        </p:spPr>
-        <p:txBody>
-          <a:bodyPr wrap="square" anchor="ctr" lIns="0" rIns="0" tIns="0" bIns="0">
-            <a:spAutoFit/>
-          </a:bodyPr>
-          <a:lstStyle/>
-          <a:p>
-            <a:pPr algn="l">
-              <a:lnSpc>
-                <a:spcPct val="100000"/>
-              </a:lnSpc>
-            </a:pPr>
-            <a:r>
-              <a:rPr sz="1200" b="1" i="0">
-                <a:solidFill>
-                  <a:srgbClr val="1A3A66"/>
-                </a:solidFill>
-                <a:latin typeface="Calibri"/>
-              </a:rPr>
-              <a:t>TAKEAWAY   </a:t>
-            </a:r>
-          </a:p>
-        </p:txBody>
-      </p:sp>
-      <p:sp>
-        <p:nvSpPr>
-          <p:cNvPr id="11" name="TextBox 10"/>
-          <p:cNvSpPr txBox="1"/>
-          <p:nvPr/>
-        </p:nvSpPr>
-        <p:spPr>
-          <a:xfrm>
-            <a:off x="1417320" y="6144768"/>
-            <a:ext cx="10362895" cy="713232"/>
-          </a:xfrm>
-          <a:prstGeom prst="rect">
-            <a:avLst/>
-          </a:prstGeom>
-          <a:noFill/>
-        </p:spPr>
-        <p:txBody>
-          <a:bodyPr wrap="square" anchor="ctr" lIns="0" rIns="0" tIns="0" bIns="0">
-            <a:spAutoFit/>
-          </a:bodyPr>
-          <a:lstStyle/>
-          <a:p>
-            <a:pPr algn="l">
-              <a:lnSpc>
-                <a:spcPct val="100000"/>
-              </a:lnSpc>
-            </a:pPr>
-            <a:r>
-              <a:rPr sz="1450" b="1" i="0">
-                <a:solidFill>
-                  <a:srgbClr val="1A3A66"/>
-                </a:solidFill>
-                <a:latin typeface="Calibri"/>
-              </a:rPr>
-              <a:t>Order of work, as agreed: data first, zero-shot baseline second (done here), physics-guided fine-tuning on GPP last.</a:t>
-            </a:r>
-          </a:p>
-        </p:txBody>
-      </p:sp>
-    </p:spTree>
-  </p:cSld>
-  <p:clrMapOvr>
-    <a:masterClrMapping/>
-  </p:clrMapOvr>
-</p:sld>
-</file>
-
 <file path=ppt/theme/theme1.xml><?xml version="1.0" encoding="utf-8"?>
 <a:theme xmlns:a="http://schemas.openxmlformats.org/drawingml/2006/main" name="Office Theme">
   <a:themeElements>

</xml_diff>

<commit_message>
Fix text-overflow bug: disable shape-autofit on all text boxes
Caught via screenshot: python-pptx's add_textbox() defaults to shape-to-
fit-text autosizing, which renders as text running off the right edge of
the slide instead of wrapping within the set width. Set auto_size =
MSO_AUTO_SIZE.NONE on both text helpers (this deck could not be visually
rendered on this host before now to catch it directly).

Co-Authored-By: Claude Sonnet 5 <noreply@anthropic.com>
</commit_message>
<xml_diff>
--- a/presentations/GPP_vs_LAI_Progress_Update/GPP_vs_LAI_Progress_Update.pptx
+++ b/presentations/GPP_vs_LAI_Progress_Update/GPP_vs_LAI_Progress_Update.pptx
@@ -3167,7 +3167,7 @@
         </p:spPr>
         <p:txBody>
           <a:bodyPr wrap="square" anchor="t" lIns="0" rIns="0" tIns="0" bIns="0">
-            <a:spAutoFit/>
+            <a:noAutofit/>
           </a:bodyPr>
           <a:lstStyle/>
           <a:p>
@@ -3206,7 +3206,7 @@
         </p:spPr>
         <p:txBody>
           <a:bodyPr wrap="square" anchor="t" lIns="0" rIns="0" tIns="0" bIns="0">
-            <a:spAutoFit/>
+            <a:noAutofit/>
           </a:bodyPr>
           <a:lstStyle/>
           <a:p>
@@ -3245,7 +3245,7 @@
         </p:spPr>
         <p:txBody>
           <a:bodyPr wrap="square" anchor="t" lIns="0" rIns="0">
-            <a:spAutoFit/>
+            <a:noAutofit/>
           </a:bodyPr>
           <a:lstStyle/>
           <a:p>
@@ -3378,7 +3378,7 @@
         </p:spPr>
         <p:txBody>
           <a:bodyPr wrap="square" anchor="t" lIns="0" rIns="0" tIns="0" bIns="0">
-            <a:spAutoFit/>
+            <a:noAutofit/>
           </a:bodyPr>
           <a:lstStyle/>
           <a:p>
@@ -3417,7 +3417,7 @@
         </p:spPr>
         <p:txBody>
           <a:bodyPr wrap="square" anchor="t" lIns="0" rIns="0" tIns="0" bIns="0">
-            <a:spAutoFit/>
+            <a:noAutofit/>
           </a:bodyPr>
           <a:lstStyle/>
           <a:p>
@@ -3500,7 +3500,7 @@
         </p:spPr>
         <p:txBody>
           <a:bodyPr wrap="square" anchor="t" lIns="0" rIns="0" tIns="0" bIns="0">
-            <a:spAutoFit/>
+            <a:noAutofit/>
           </a:bodyPr>
           <a:lstStyle/>
           <a:p>
@@ -3539,7 +3539,7 @@
         </p:spPr>
         <p:txBody>
           <a:bodyPr wrap="square" anchor="t" lIns="0" rIns="0">
-            <a:spAutoFit/>
+            <a:noAutofit/>
           </a:bodyPr>
           <a:lstStyle/>
           <a:p>
@@ -3618,7 +3618,7 @@
         </p:spPr>
         <p:txBody>
           <a:bodyPr wrap="square" anchor="t" lIns="0" rIns="0">
-            <a:spAutoFit/>
+            <a:noAutofit/>
           </a:bodyPr>
           <a:lstStyle/>
           <a:p>
@@ -3785,7 +3785,7 @@
         </p:spPr>
         <p:txBody>
           <a:bodyPr wrap="square" anchor="ctr" lIns="0" rIns="0" tIns="0" bIns="0">
-            <a:spAutoFit/>
+            <a:noAutofit/>
           </a:bodyPr>
           <a:lstStyle/>
           <a:p>
@@ -3824,7 +3824,7 @@
         </p:spPr>
         <p:txBody>
           <a:bodyPr wrap="square" anchor="ctr" lIns="0" rIns="0" tIns="0" bIns="0">
-            <a:spAutoFit/>
+            <a:noAutofit/>
           </a:bodyPr>
           <a:lstStyle/>
           <a:p>
@@ -3889,7 +3889,7 @@
         </p:spPr>
         <p:txBody>
           <a:bodyPr wrap="square" anchor="t" lIns="0" rIns="0" tIns="0" bIns="0">
-            <a:spAutoFit/>
+            <a:noAutofit/>
           </a:bodyPr>
           <a:lstStyle/>
           <a:p>
@@ -3928,7 +3928,7 @@
         </p:spPr>
         <p:txBody>
           <a:bodyPr wrap="square" anchor="t" lIns="0" rIns="0" tIns="0" bIns="0">
-            <a:spAutoFit/>
+            <a:noAutofit/>
           </a:bodyPr>
           <a:lstStyle/>
           <a:p>
@@ -4011,7 +4011,7 @@
         </p:spPr>
         <p:txBody>
           <a:bodyPr wrap="square" anchor="t" lIns="0" rIns="0" tIns="0" bIns="0">
-            <a:spAutoFit/>
+            <a:noAutofit/>
           </a:bodyPr>
           <a:lstStyle/>
           <a:p>
@@ -4050,7 +4050,7 @@
         </p:spPr>
         <p:txBody>
           <a:bodyPr wrap="square" anchor="t" lIns="0" rIns="0">
-            <a:spAutoFit/>
+            <a:noAutofit/>
           </a:bodyPr>
           <a:lstStyle/>
           <a:p>
@@ -4245,7 +4245,7 @@
         </p:spPr>
         <p:txBody>
           <a:bodyPr wrap="square" anchor="ctr" lIns="0" rIns="0" tIns="0" bIns="0">
-            <a:spAutoFit/>
+            <a:noAutofit/>
           </a:bodyPr>
           <a:lstStyle/>
           <a:p>
@@ -4284,7 +4284,7 @@
         </p:spPr>
         <p:txBody>
           <a:bodyPr wrap="square" anchor="ctr" lIns="0" rIns="0" tIns="0" bIns="0">
-            <a:spAutoFit/>
+            <a:noAutofit/>
           </a:bodyPr>
           <a:lstStyle/>
           <a:p>
@@ -4349,7 +4349,7 @@
         </p:spPr>
         <p:txBody>
           <a:bodyPr wrap="square" anchor="t" lIns="0" rIns="0" tIns="0" bIns="0">
-            <a:spAutoFit/>
+            <a:noAutofit/>
           </a:bodyPr>
           <a:lstStyle/>
           <a:p>
@@ -4388,7 +4388,7 @@
         </p:spPr>
         <p:txBody>
           <a:bodyPr wrap="square" anchor="t" lIns="0" rIns="0" tIns="0" bIns="0">
-            <a:spAutoFit/>
+            <a:noAutofit/>
           </a:bodyPr>
           <a:lstStyle/>
           <a:p>
@@ -4471,7 +4471,7 @@
         </p:spPr>
         <p:txBody>
           <a:bodyPr wrap="square" anchor="t" lIns="0" rIns="0" tIns="0" bIns="0">
-            <a:spAutoFit/>
+            <a:noAutofit/>
           </a:bodyPr>
           <a:lstStyle/>
           <a:p>
@@ -4622,7 +4622,7 @@
         </p:spPr>
         <p:txBody>
           <a:bodyPr wrap="square" anchor="ctr" lIns="0" rIns="0" tIns="0" bIns="0">
-            <a:spAutoFit/>
+            <a:noAutofit/>
           </a:bodyPr>
           <a:lstStyle/>
           <a:p>
@@ -4661,7 +4661,7 @@
         </p:spPr>
         <p:txBody>
           <a:bodyPr wrap="square" anchor="ctr" lIns="0" rIns="0" tIns="0" bIns="0">
-            <a:spAutoFit/>
+            <a:noAutofit/>
           </a:bodyPr>
           <a:lstStyle/>
           <a:p>
@@ -4726,7 +4726,7 @@
         </p:spPr>
         <p:txBody>
           <a:bodyPr wrap="square" anchor="t" lIns="0" rIns="0" tIns="0" bIns="0">
-            <a:spAutoFit/>
+            <a:noAutofit/>
           </a:bodyPr>
           <a:lstStyle/>
           <a:p>
@@ -4765,7 +4765,7 @@
         </p:spPr>
         <p:txBody>
           <a:bodyPr wrap="square" anchor="t" lIns="0" rIns="0" tIns="0" bIns="0">
-            <a:spAutoFit/>
+            <a:noAutofit/>
           </a:bodyPr>
           <a:lstStyle/>
           <a:p>
@@ -4848,7 +4848,7 @@
         </p:spPr>
         <p:txBody>
           <a:bodyPr wrap="square" anchor="t" lIns="0" rIns="0" tIns="0" bIns="0">
-            <a:spAutoFit/>
+            <a:noAutofit/>
           </a:bodyPr>
           <a:lstStyle/>
           <a:p>
@@ -4999,7 +4999,7 @@
         </p:spPr>
         <p:txBody>
           <a:bodyPr wrap="square" anchor="ctr" lIns="0" rIns="0" tIns="0" bIns="0">
-            <a:spAutoFit/>
+            <a:noAutofit/>
           </a:bodyPr>
           <a:lstStyle/>
           <a:p>
@@ -5038,7 +5038,7 @@
         </p:spPr>
         <p:txBody>
           <a:bodyPr wrap="square" anchor="ctr" lIns="0" rIns="0" tIns="0" bIns="0">
-            <a:spAutoFit/>
+            <a:noAutofit/>
           </a:bodyPr>
           <a:lstStyle/>
           <a:p>
@@ -5103,7 +5103,7 @@
         </p:spPr>
         <p:txBody>
           <a:bodyPr wrap="square" anchor="t" lIns="0" rIns="0" tIns="0" bIns="0">
-            <a:spAutoFit/>
+            <a:noAutofit/>
           </a:bodyPr>
           <a:lstStyle/>
           <a:p>
@@ -5142,7 +5142,7 @@
         </p:spPr>
         <p:txBody>
           <a:bodyPr wrap="square" anchor="t" lIns="0" rIns="0" tIns="0" bIns="0">
-            <a:spAutoFit/>
+            <a:noAutofit/>
           </a:bodyPr>
           <a:lstStyle/>
           <a:p>
@@ -5225,7 +5225,7 @@
         </p:spPr>
         <p:txBody>
           <a:bodyPr wrap="square" anchor="t" lIns="0" rIns="0" tIns="0" bIns="0">
-            <a:spAutoFit/>
+            <a:noAutofit/>
           </a:bodyPr>
           <a:lstStyle/>
           <a:p>
@@ -5575,7 +5575,7 @@
         </p:spPr>
         <p:txBody>
           <a:bodyPr wrap="square" anchor="t" lIns="0" rIns="0">
-            <a:spAutoFit/>
+            <a:noAutofit/>
           </a:bodyPr>
           <a:lstStyle/>
           <a:p>
@@ -5742,7 +5742,7 @@
         </p:spPr>
         <p:txBody>
           <a:bodyPr wrap="square" anchor="ctr" lIns="0" rIns="0" tIns="0" bIns="0">
-            <a:spAutoFit/>
+            <a:noAutofit/>
           </a:bodyPr>
           <a:lstStyle/>
           <a:p>
@@ -5781,7 +5781,7 @@
         </p:spPr>
         <p:txBody>
           <a:bodyPr wrap="square" anchor="ctr" lIns="0" rIns="0" tIns="0" bIns="0">
-            <a:spAutoFit/>
+            <a:noAutofit/>
           </a:bodyPr>
           <a:lstStyle/>
           <a:p>
@@ -5846,7 +5846,7 @@
         </p:spPr>
         <p:txBody>
           <a:bodyPr wrap="square" anchor="t" lIns="0" rIns="0" tIns="0" bIns="0">
-            <a:spAutoFit/>
+            <a:noAutofit/>
           </a:bodyPr>
           <a:lstStyle/>
           <a:p>
@@ -5885,7 +5885,7 @@
         </p:spPr>
         <p:txBody>
           <a:bodyPr wrap="square" anchor="t" lIns="0" rIns="0" tIns="0" bIns="0">
-            <a:spAutoFit/>
+            <a:noAutofit/>
           </a:bodyPr>
           <a:lstStyle/>
           <a:p>
@@ -5968,7 +5968,7 @@
         </p:spPr>
         <p:txBody>
           <a:bodyPr wrap="square" anchor="t" lIns="0" rIns="0" tIns="0" bIns="0">
-            <a:spAutoFit/>
+            <a:noAutofit/>
           </a:bodyPr>
           <a:lstStyle/>
           <a:p>
@@ -6007,7 +6007,7 @@
         </p:spPr>
         <p:txBody>
           <a:bodyPr wrap="square" anchor="t" lIns="0" rIns="0">
-            <a:spAutoFit/>
+            <a:noAutofit/>
           </a:bodyPr>
           <a:lstStyle/>
           <a:p>
@@ -6457,7 +6457,7 @@
         </p:spPr>
         <p:txBody>
           <a:bodyPr wrap="square" anchor="ctr" lIns="0" rIns="0" tIns="0" bIns="0">
-            <a:spAutoFit/>
+            <a:noAutofit/>
           </a:bodyPr>
           <a:lstStyle/>
           <a:p>
@@ -6496,7 +6496,7 @@
         </p:spPr>
         <p:txBody>
           <a:bodyPr wrap="square" anchor="ctr" lIns="0" rIns="0" tIns="0" bIns="0">
-            <a:spAutoFit/>
+            <a:noAutofit/>
           </a:bodyPr>
           <a:lstStyle/>
           <a:p>
@@ -6561,7 +6561,7 @@
         </p:spPr>
         <p:txBody>
           <a:bodyPr wrap="square" anchor="t" lIns="0" rIns="0" tIns="0" bIns="0">
-            <a:spAutoFit/>
+            <a:noAutofit/>
           </a:bodyPr>
           <a:lstStyle/>
           <a:p>
@@ -6600,7 +6600,7 @@
         </p:spPr>
         <p:txBody>
           <a:bodyPr wrap="square" anchor="t" lIns="0" rIns="0" tIns="0" bIns="0">
-            <a:spAutoFit/>
+            <a:noAutofit/>
           </a:bodyPr>
           <a:lstStyle/>
           <a:p>
@@ -6683,7 +6683,7 @@
         </p:spPr>
         <p:txBody>
           <a:bodyPr wrap="square" anchor="t" lIns="0" rIns="0" tIns="0" bIns="0">
-            <a:spAutoFit/>
+            <a:noAutofit/>
           </a:bodyPr>
           <a:lstStyle/>
           <a:p>
@@ -6722,7 +6722,7 @@
         </p:spPr>
         <p:txBody>
           <a:bodyPr wrap="square" anchor="t" lIns="0" rIns="0">
-            <a:spAutoFit/>
+            <a:noAutofit/>
           </a:bodyPr>
           <a:lstStyle/>
           <a:p>
@@ -6917,7 +6917,7 @@
         </p:spPr>
         <p:txBody>
           <a:bodyPr wrap="square" anchor="ctr" lIns="0" rIns="0" tIns="0" bIns="0">
-            <a:spAutoFit/>
+            <a:noAutofit/>
           </a:bodyPr>
           <a:lstStyle/>
           <a:p>
@@ -6956,7 +6956,7 @@
         </p:spPr>
         <p:txBody>
           <a:bodyPr wrap="square" anchor="ctr" lIns="0" rIns="0" tIns="0" bIns="0">
-            <a:spAutoFit/>
+            <a:noAutofit/>
           </a:bodyPr>
           <a:lstStyle/>
           <a:p>
@@ -7021,7 +7021,7 @@
         </p:spPr>
         <p:txBody>
           <a:bodyPr wrap="square" anchor="t" lIns="0" rIns="0" tIns="0" bIns="0">
-            <a:spAutoFit/>
+            <a:noAutofit/>
           </a:bodyPr>
           <a:lstStyle/>
           <a:p>
@@ -7060,7 +7060,7 @@
         </p:spPr>
         <p:txBody>
           <a:bodyPr wrap="square" anchor="t" lIns="0" rIns="0" tIns="0" bIns="0">
-            <a:spAutoFit/>
+            <a:noAutofit/>
           </a:bodyPr>
           <a:lstStyle/>
           <a:p>
@@ -7143,7 +7143,7 @@
         </p:spPr>
         <p:txBody>
           <a:bodyPr wrap="square" anchor="t" lIns="0" rIns="0" tIns="0" bIns="0">
-            <a:spAutoFit/>
+            <a:noAutofit/>
           </a:bodyPr>
           <a:lstStyle/>
           <a:p>
@@ -7182,7 +7182,7 @@
         </p:spPr>
         <p:txBody>
           <a:bodyPr wrap="square" anchor="t" lIns="0" rIns="0">
-            <a:spAutoFit/>
+            <a:noAutofit/>
           </a:bodyPr>
           <a:lstStyle/>
           <a:p>
@@ -7701,7 +7701,7 @@
         </p:spPr>
         <p:txBody>
           <a:bodyPr wrap="square" anchor="ctr" lIns="0" rIns="0" tIns="0" bIns="0">
-            <a:spAutoFit/>
+            <a:noAutofit/>
           </a:bodyPr>
           <a:lstStyle/>
           <a:p>
@@ -7740,7 +7740,7 @@
         </p:spPr>
         <p:txBody>
           <a:bodyPr wrap="square" anchor="ctr" lIns="0" rIns="0" tIns="0" bIns="0">
-            <a:spAutoFit/>
+            <a:noAutofit/>
           </a:bodyPr>
           <a:lstStyle/>
           <a:p>
@@ -7805,7 +7805,7 @@
         </p:spPr>
         <p:txBody>
           <a:bodyPr wrap="square" anchor="t" lIns="0" rIns="0" tIns="0" bIns="0">
-            <a:spAutoFit/>
+            <a:noAutofit/>
           </a:bodyPr>
           <a:lstStyle/>
           <a:p>
@@ -7844,7 +7844,7 @@
         </p:spPr>
         <p:txBody>
           <a:bodyPr wrap="square" anchor="t" lIns="0" rIns="0" tIns="0" bIns="0">
-            <a:spAutoFit/>
+            <a:noAutofit/>
           </a:bodyPr>
           <a:lstStyle/>
           <a:p>
@@ -7927,7 +7927,7 @@
         </p:spPr>
         <p:txBody>
           <a:bodyPr wrap="square" anchor="t" lIns="0" rIns="0" tIns="0" bIns="0">
-            <a:spAutoFit/>
+            <a:noAutofit/>
           </a:bodyPr>
           <a:lstStyle/>
           <a:p>
@@ -8928,7 +8928,7 @@
         </p:spPr>
         <p:txBody>
           <a:bodyPr wrap="square" anchor="ctr" lIns="0" rIns="0" tIns="0" bIns="0">
-            <a:spAutoFit/>
+            <a:noAutofit/>
           </a:bodyPr>
           <a:lstStyle/>
           <a:p>
@@ -8967,7 +8967,7 @@
         </p:spPr>
         <p:txBody>
           <a:bodyPr wrap="square" anchor="ctr" lIns="0" rIns="0" tIns="0" bIns="0">
-            <a:spAutoFit/>
+            <a:noAutofit/>
           </a:bodyPr>
           <a:lstStyle/>
           <a:p>

</xml_diff>